<commit_message>
docs: remove the ask from the final slide of the 10-slide deck
Co-Authored-By: Claude Opus 5.5 <noreply@anthropic.com>
Claude-Session: https://claude.ai/code/session_012DT45KpxUQbVV43mbMd9KB
</commit_message>
<xml_diff>
--- a/docs/presentation/CodemixSkill-Final-10-Slides.pptx
+++ b/docs/presentation/CodemixSkill-Final-10-Slides.pptx
@@ -3087,7 +3087,7 @@
                 <a:ea typeface="Cambria" pitchFamily="34" charset="-122"/>
                 <a:cs typeface="Cambria" pitchFamily="34" charset="-120"/>
               </a:rPr>
-              <a:t>Costs, Success Metrics, Risks &amp; The Ask</a:t>
+              <a:t>Costs, Success Metrics &amp; Risks</a:t>
             </a:r>
             <a:endParaRPr lang="en-US" sz="3000" dirty="0"/>
           </a:p>
@@ -5739,25 +5739,11 @@
           <a:bodyPr wrap="square" lIns="0" tIns="0" rIns="0" bIns="0" rtlCol="0" anchor="ctr"/>
           <a:lstStyle/>
           <a:p>
-            <a:pPr indent="0" marL="0">
-              <a:buNone/>
-            </a:pPr>
-            <a:r>
-              <a:rPr lang="en-US" sz="1300" b="1" dirty="0">
-                <a:solidFill>
-                  <a:srgbClr val="F4A300"/>
-                </a:solidFill>
-                <a:latin typeface="Calibri" pitchFamily="34" charset="0"/>
-                <a:ea typeface="Calibri" pitchFamily="34" charset="-122"/>
-                <a:cs typeface="Calibri" pitchFamily="34" charset="-120"/>
-              </a:rPr>
-              <a:t>OUR ASK  </a:t>
-            </a:r>
-            <a:pPr indent="0" marL="0">
-              <a:buNone/>
-            </a:pPr>
-            <a:r>
-              <a:rPr lang="en-US" sz="1300" b="1" dirty="0">
+            <a:pPr algn="ctr" indent="0" marL="0">
+              <a:buNone/>
+            </a:pPr>
+            <a:r>
+              <a:rPr lang="en-US" sz="1400" b="1" dirty="0">
                 <a:solidFill>
                   <a:srgbClr val="FFFFFF"/>
                 </a:solidFill>
@@ -5765,13 +5751,13 @@
                 <a:ea typeface="Calibri" pitchFamily="34" charset="-122"/>
                 <a:cs typeface="Calibri" pitchFamily="34" charset="-120"/>
               </a:rPr>
-              <a:t>Freshdesk sandbox + Marketplace listing path for a 3-brand pilot.   </a:t>
-            </a:r>
-            <a:pPr indent="0" marL="0">
-              <a:buNone/>
-            </a:pPr>
-            <a:r>
-              <a:rPr lang="en-US" sz="1300" i="1" dirty="0">
+              <a:t>“Don't cancel” should mean don't cancel.</a:t>
+            </a:r>
+            <a:pPr algn="ctr" indent="0" marL="0">
+              <a:buNone/>
+            </a:pPr>
+            <a:r>
+              <a:rPr lang="en-US" sz="1400" dirty="0">
                 <a:solidFill>
                   <a:srgbClr val="CADCFC"/>
                 </a:solidFill>
@@ -5779,9 +5765,9 @@
                 <a:ea typeface="Calibri" pitchFamily="34" charset="-122"/>
                 <a:cs typeface="Calibri" pitchFamily="34" charset="-120"/>
               </a:rPr>
-              <a:t>“Don't cancel” should mean don't cancel.</a:t>
-            </a:r>
-            <a:endParaRPr lang="en-US" sz="1300" dirty="0"/>
+              <a:t>   Codemix Skill  ·  Understand → Decide → Act → Audit</a:t>
+            </a:r>
+            <a:endParaRPr lang="en-US" sz="1400" dirty="0"/>
           </a:p>
         </p:txBody>
       </p:sp>

</xml_diff>

<commit_message>
docs: add ROI strip to the 10-slide deck
Customer ROI (~2.3x, break-even at 9 prevented wrong refunds a month)
and Freshworks ROI (~1.3x Year 1, ~9-month payback), labelled as
illustrative and built on the deck's pricing assumptions.

Co-Authored-By: Claude Opus 5.5 <noreply@anthropic.com>
Claude-Session: https://claude.ai/code/session_012DT45KpxUQbVV43mbMd9KB
</commit_message>
<xml_diff>
--- a/docs/presentation/CodemixSkill-Final-10-Slides.pptx
+++ b/docs/presentation/CodemixSkill-Final-10-Slides.pptx
@@ -2984,7 +2984,7 @@
                 <a:ea typeface="Calibri" pitchFamily="34" charset="-122"/>
                 <a:cs typeface="Calibri" pitchFamily="34" charset="-120"/>
               </a:rPr>
-              <a:t>SECTIONS 10–12 OF 12  ·  COSTS  ·  METRICS  ·  RISKS &amp; ASSUMPTIONS</a:t>
+              <a:t>SECTIONS 10–12 OF 12  ·  COSTS &amp; ROI  ·  METRICS  ·  RISKS &amp; ASSUMPTIONS</a:t>
             </a:r>
             <a:endParaRPr lang="en-US" sz="900" dirty="0"/>
           </a:p>
@@ -3087,7 +3087,7 @@
                 <a:ea typeface="Cambria" pitchFamily="34" charset="-122"/>
                 <a:cs typeface="Cambria" pitchFamily="34" charset="-120"/>
               </a:rPr>
-              <a:t>Costs, Success Metrics &amp; Risks</a:t>
+              <a:t>Costs, ROI, Success Metrics &amp; Risks</a:t>
             </a:r>
             <a:endParaRPr lang="en-US" sz="3000" dirty="0"/>
           </a:p>
@@ -3126,7 +3126,7 @@
                 <a:ea typeface="Calibri" pitchFamily="34" charset="-122"/>
                 <a:cs typeface="Calibri" pitchFamily="34" charset="-120"/>
               </a:rPr>
-              <a:t>Estimates and targets are labelled; two baselines are already measured</a:t>
+              <a:t>What it costs, what it returns, how we measure it, and what could go wrong</a:t>
             </a:r>
             <a:endParaRPr lang="en-US" sz="1350" dirty="0"/>
           </a:p>
@@ -3141,11 +3141,11 @@
         <p:spPr>
           <a:xfrm>
             <a:off x="548640" y="1572768"/>
-            <a:ext cx="3566160" cy="3931920"/>
+            <a:ext cx="3566160" cy="3456432"/>
           </a:xfrm>
           <a:prstGeom prst="roundRect">
             <a:avLst>
-              <a:gd name="adj" fmla="val 2564"/>
+              <a:gd name="adj" fmla="val 2646"/>
             </a:avLst>
           </a:prstGeom>
           <a:solidFill>
@@ -3863,8 +3863,8 @@
         </p:nvSpPr>
         <p:spPr>
           <a:xfrm>
-            <a:off x="731520" y="4434840"/>
-            <a:ext cx="3337560" cy="1005840"/>
+            <a:off x="731520" y="4389120"/>
+            <a:ext cx="3337560" cy="548640"/>
           </a:xfrm>
           <a:prstGeom prst="rect">
             <a:avLst/>
@@ -3877,9 +3877,6 @@
           <a:lstStyle/>
           <a:p>
             <a:pPr indent="0" marL="0">
-              <a:spcAft>
-                <a:spcPts val="400"/>
-              </a:spcAft>
               <a:buNone/>
             </a:pPr>
             <a:r>
@@ -3894,9 +3891,6 @@
               <a:t>Timeline: </a:t>
             </a:r>
             <a:pPr indent="0" marL="0">
-              <a:spcAft>
-                <a:spcPts val="400"/>
-              </a:spcAft>
               <a:buNone/>
             </a:pPr>
             <a:r>
@@ -3909,77 +3903,6 @@
                 <a:cs typeface="Calibri" pitchFamily="34" charset="-120"/>
               </a:rPr>
               <a:t>M1 negation data · M2 Claude gate, Dodo, voice path · M3 Freshdesk, audit, pilot</a:t>
-            </a:r>
-            <a:endParaRPr lang="en-US" sz="1000" dirty="0"/>
-          </a:p>
-          <a:p>
-            <a:pPr indent="0" marL="0">
-              <a:spcAft>
-                <a:spcPts val="400"/>
-              </a:spcAft>
-              <a:buNone/>
-            </a:pPr>
-            <a:r>
-              <a:rPr lang="en-US" sz="1000" b="1" dirty="0">
-                <a:solidFill>
-                  <a:srgbClr val="14213D"/>
-                </a:solidFill>
-                <a:latin typeface="Calibri" pitchFamily="34" charset="0"/>
-                <a:ea typeface="Calibri" pitchFamily="34" charset="-122"/>
-                <a:cs typeface="Calibri" pitchFamily="34" charset="-120"/>
-              </a:rPr>
-              <a:t>Optional: </a:t>
-            </a:r>
-            <a:pPr indent="0" marL="0">
-              <a:spcAft>
-                <a:spcPts val="400"/>
-              </a:spcAft>
-              <a:buNone/>
-            </a:pPr>
-            <a:r>
-              <a:rPr lang="en-US" sz="1000" dirty="0">
-                <a:solidFill>
-                  <a:srgbClr val="1F2937"/>
-                </a:solidFill>
-                <a:latin typeface="Calibri" pitchFamily="34" charset="0"/>
-                <a:ea typeface="Calibri" pitchFamily="34" charset="-122"/>
-                <a:cs typeface="Calibri" pitchFamily="34" charset="-120"/>
-              </a:rPr>
-              <a:t>100 customers × 20K actions/mo × $5/1K ≈ </a:t>
-            </a:r>
-            <a:pPr indent="0" marL="0">
-              <a:spcAft>
-                <a:spcPts val="400"/>
-              </a:spcAft>
-              <a:buNone/>
-            </a:pPr>
-            <a:r>
-              <a:rPr lang="en-US" sz="1000" b="1" dirty="0">
-                <a:solidFill>
-                  <a:srgbClr val="1F8A63"/>
-                </a:solidFill>
-                <a:latin typeface="Calibri" pitchFamily="34" charset="0"/>
-                <a:ea typeface="Calibri" pitchFamily="34" charset="-122"/>
-                <a:cs typeface="Calibri" pitchFamily="34" charset="-120"/>
-              </a:rPr>
-              <a:t>$120K ARR</a:t>
-            </a:r>
-            <a:pPr indent="0" marL="0">
-              <a:spcAft>
-                <a:spcPts val="400"/>
-              </a:spcAft>
-              <a:buNone/>
-            </a:pPr>
-            <a:r>
-              <a:rPr lang="en-US" sz="1000" dirty="0">
-                <a:solidFill>
-                  <a:srgbClr val="5B6475"/>
-                </a:solidFill>
-                <a:latin typeface="Calibri" pitchFamily="34" charset="0"/>
-                <a:ea typeface="Calibri" pitchFamily="34" charset="-122"/>
-                <a:cs typeface="Calibri" pitchFamily="34" charset="-120"/>
-              </a:rPr>
-              <a:t> (assumption)</a:t>
             </a:r>
             <a:endParaRPr lang="en-US" sz="1000" dirty="0"/>
           </a:p>
@@ -3994,11 +3917,11 @@
         <p:spPr>
           <a:xfrm>
             <a:off x="4361688" y="1572768"/>
-            <a:ext cx="3566160" cy="3931920"/>
+            <a:ext cx="3566160" cy="3456432"/>
           </a:xfrm>
           <a:prstGeom prst="roundRect">
             <a:avLst>
-              <a:gd name="adj" fmla="val 2564"/>
+              <a:gd name="adj" fmla="val 2646"/>
             </a:avLst>
           </a:prstGeom>
           <a:solidFill>
@@ -4191,8 +4114,8 @@
         </p:nvSpPr>
         <p:spPr>
           <a:xfrm>
-            <a:off x="4453128" y="2331720"/>
-            <a:ext cx="3337560" cy="347472"/>
+            <a:off x="4453128" y="2304288"/>
+            <a:ext cx="3337560" cy="310896"/>
           </a:xfrm>
           <a:prstGeom prst="rect">
             <a:avLst/>
@@ -4216,8 +4139,8 @@
         </p:nvSpPr>
         <p:spPr>
           <a:xfrm>
-            <a:off x="4526280" y="2331720"/>
-            <a:ext cx="1828800" cy="347472"/>
+            <a:off x="4526280" y="2304288"/>
+            <a:ext cx="1828800" cy="310896"/>
           </a:xfrm>
           <a:prstGeom prst="rect">
             <a:avLst/>
@@ -4255,8 +4178,8 @@
         </p:nvSpPr>
         <p:spPr>
           <a:xfrm>
-            <a:off x="6355080" y="2331720"/>
-            <a:ext cx="731520" cy="347472"/>
+            <a:off x="6355080" y="2304288"/>
+            <a:ext cx="731520" cy="310896"/>
           </a:xfrm>
           <a:prstGeom prst="rect">
             <a:avLst/>
@@ -4294,8 +4217,8 @@
         </p:nvSpPr>
         <p:spPr>
           <a:xfrm>
-            <a:off x="7059168" y="2331720"/>
-            <a:ext cx="731520" cy="347472"/>
+            <a:off x="7059168" y="2304288"/>
+            <a:ext cx="731520" cy="310896"/>
           </a:xfrm>
           <a:prstGeom prst="rect">
             <a:avLst/>
@@ -4333,8 +4256,8 @@
         </p:nvSpPr>
         <p:spPr>
           <a:xfrm>
-            <a:off x="4453128" y="2715768"/>
-            <a:ext cx="3337560" cy="347472"/>
+            <a:off x="4453128" y="2642616"/>
+            <a:ext cx="3337560" cy="310896"/>
           </a:xfrm>
           <a:prstGeom prst="rect">
             <a:avLst/>
@@ -4358,8 +4281,8 @@
         </p:nvSpPr>
         <p:spPr>
           <a:xfrm>
-            <a:off x="4526280" y="2715768"/>
-            <a:ext cx="1828800" cy="347472"/>
+            <a:off x="4526280" y="2642616"/>
+            <a:ext cx="1828800" cy="310896"/>
           </a:xfrm>
           <a:prstGeom prst="rect">
             <a:avLst/>
@@ -4397,8 +4320,8 @@
         </p:nvSpPr>
         <p:spPr>
           <a:xfrm>
-            <a:off x="6355080" y="2715768"/>
-            <a:ext cx="731520" cy="347472"/>
+            <a:off x="6355080" y="2642616"/>
+            <a:ext cx="731520" cy="310896"/>
           </a:xfrm>
           <a:prstGeom prst="rect">
             <a:avLst/>
@@ -4436,8 +4359,8 @@
         </p:nvSpPr>
         <p:spPr>
           <a:xfrm>
-            <a:off x="7059168" y="2715768"/>
-            <a:ext cx="731520" cy="347472"/>
+            <a:off x="7059168" y="2642616"/>
+            <a:ext cx="731520" cy="310896"/>
           </a:xfrm>
           <a:prstGeom prst="rect">
             <a:avLst/>
@@ -4475,8 +4398,8 @@
         </p:nvSpPr>
         <p:spPr>
           <a:xfrm>
-            <a:off x="4453128" y="3099816"/>
-            <a:ext cx="3337560" cy="347472"/>
+            <a:off x="4453128" y="2980944"/>
+            <a:ext cx="3337560" cy="310896"/>
           </a:xfrm>
           <a:prstGeom prst="rect">
             <a:avLst/>
@@ -4500,8 +4423,8 @@
         </p:nvSpPr>
         <p:spPr>
           <a:xfrm>
-            <a:off x="4526280" y="3099816"/>
-            <a:ext cx="1828800" cy="347472"/>
+            <a:off x="4526280" y="2980944"/>
+            <a:ext cx="1828800" cy="310896"/>
           </a:xfrm>
           <a:prstGeom prst="rect">
             <a:avLst/>
@@ -4539,8 +4462,8 @@
         </p:nvSpPr>
         <p:spPr>
           <a:xfrm>
-            <a:off x="6355080" y="3099816"/>
-            <a:ext cx="731520" cy="347472"/>
+            <a:off x="6355080" y="2980944"/>
+            <a:ext cx="731520" cy="310896"/>
           </a:xfrm>
           <a:prstGeom prst="rect">
             <a:avLst/>
@@ -4578,8 +4501,8 @@
         </p:nvSpPr>
         <p:spPr>
           <a:xfrm>
-            <a:off x="7059168" y="3099816"/>
-            <a:ext cx="731520" cy="347472"/>
+            <a:off x="7059168" y="2980944"/>
+            <a:ext cx="731520" cy="310896"/>
           </a:xfrm>
           <a:prstGeom prst="rect">
             <a:avLst/>
@@ -4617,8 +4540,8 @@
         </p:nvSpPr>
         <p:spPr>
           <a:xfrm>
-            <a:off x="4453128" y="3483864"/>
-            <a:ext cx="3337560" cy="347472"/>
+            <a:off x="4453128" y="3319272"/>
+            <a:ext cx="3337560" cy="310896"/>
           </a:xfrm>
           <a:prstGeom prst="rect">
             <a:avLst/>
@@ -4642,8 +4565,8 @@
         </p:nvSpPr>
         <p:spPr>
           <a:xfrm>
-            <a:off x="4526280" y="3483864"/>
-            <a:ext cx="1828800" cy="347472"/>
+            <a:off x="4526280" y="3319272"/>
+            <a:ext cx="1828800" cy="310896"/>
           </a:xfrm>
           <a:prstGeom prst="rect">
             <a:avLst/>
@@ -4681,8 +4604,8 @@
         </p:nvSpPr>
         <p:spPr>
           <a:xfrm>
-            <a:off x="6355080" y="3483864"/>
-            <a:ext cx="731520" cy="347472"/>
+            <a:off x="6355080" y="3319272"/>
+            <a:ext cx="731520" cy="310896"/>
           </a:xfrm>
           <a:prstGeom prst="rect">
             <a:avLst/>
@@ -4720,8 +4643,8 @@
         </p:nvSpPr>
         <p:spPr>
           <a:xfrm>
-            <a:off x="7059168" y="3483864"/>
-            <a:ext cx="731520" cy="347472"/>
+            <a:off x="7059168" y="3319272"/>
+            <a:ext cx="731520" cy="310896"/>
           </a:xfrm>
           <a:prstGeom prst="rect">
             <a:avLst/>
@@ -4759,8 +4682,8 @@
         </p:nvSpPr>
         <p:spPr>
           <a:xfrm>
-            <a:off x="4453128" y="3867912"/>
-            <a:ext cx="3337560" cy="347472"/>
+            <a:off x="4453128" y="3657600"/>
+            <a:ext cx="3337560" cy="310896"/>
           </a:xfrm>
           <a:prstGeom prst="rect">
             <a:avLst/>
@@ -4784,8 +4707,8 @@
         </p:nvSpPr>
         <p:spPr>
           <a:xfrm>
-            <a:off x="4526280" y="3867912"/>
-            <a:ext cx="1828800" cy="347472"/>
+            <a:off x="4526280" y="3657600"/>
+            <a:ext cx="1828800" cy="310896"/>
           </a:xfrm>
           <a:prstGeom prst="rect">
             <a:avLst/>
@@ -4823,8 +4746,8 @@
         </p:nvSpPr>
         <p:spPr>
           <a:xfrm>
-            <a:off x="6355080" y="3867912"/>
-            <a:ext cx="731520" cy="347472"/>
+            <a:off x="6355080" y="3657600"/>
+            <a:ext cx="731520" cy="310896"/>
           </a:xfrm>
           <a:prstGeom prst="rect">
             <a:avLst/>
@@ -4862,8 +4785,8 @@
         </p:nvSpPr>
         <p:spPr>
           <a:xfrm>
-            <a:off x="7059168" y="3867912"/>
-            <a:ext cx="731520" cy="347472"/>
+            <a:off x="7059168" y="3657600"/>
+            <a:ext cx="731520" cy="310896"/>
           </a:xfrm>
           <a:prstGeom prst="rect">
             <a:avLst/>
@@ -4901,8 +4824,8 @@
         </p:nvSpPr>
         <p:spPr>
           <a:xfrm>
-            <a:off x="4453128" y="4251960"/>
-            <a:ext cx="3337560" cy="347472"/>
+            <a:off x="4453128" y="3995928"/>
+            <a:ext cx="3337560" cy="310896"/>
           </a:xfrm>
           <a:prstGeom prst="rect">
             <a:avLst/>
@@ -4926,8 +4849,8 @@
         </p:nvSpPr>
         <p:spPr>
           <a:xfrm>
-            <a:off x="4526280" y="4251960"/>
-            <a:ext cx="1828800" cy="347472"/>
+            <a:off x="4526280" y="3995928"/>
+            <a:ext cx="1828800" cy="310896"/>
           </a:xfrm>
           <a:prstGeom prst="rect">
             <a:avLst/>
@@ -4965,8 +4888,8 @@
         </p:nvSpPr>
         <p:spPr>
           <a:xfrm>
-            <a:off x="6355080" y="4251960"/>
-            <a:ext cx="731520" cy="347472"/>
+            <a:off x="6355080" y="3995928"/>
+            <a:ext cx="731520" cy="310896"/>
           </a:xfrm>
           <a:prstGeom prst="rect">
             <a:avLst/>
@@ -5004,8 +4927,8 @@
         </p:nvSpPr>
         <p:spPr>
           <a:xfrm>
-            <a:off x="7059168" y="4251960"/>
-            <a:ext cx="731520" cy="347472"/>
+            <a:off x="7059168" y="3995928"/>
+            <a:ext cx="731520" cy="310896"/>
           </a:xfrm>
           <a:prstGeom prst="rect">
             <a:avLst/>
@@ -5043,8 +4966,8 @@
         </p:nvSpPr>
         <p:spPr>
           <a:xfrm>
-            <a:off x="4453128" y="4636008"/>
-            <a:ext cx="3337560" cy="347472"/>
+            <a:off x="4453128" y="4334256"/>
+            <a:ext cx="3337560" cy="310896"/>
           </a:xfrm>
           <a:prstGeom prst="rect">
             <a:avLst/>
@@ -5068,8 +4991,8 @@
         </p:nvSpPr>
         <p:spPr>
           <a:xfrm>
-            <a:off x="4526280" y="4636008"/>
-            <a:ext cx="1828800" cy="347472"/>
+            <a:off x="4526280" y="4334256"/>
+            <a:ext cx="1828800" cy="310896"/>
           </a:xfrm>
           <a:prstGeom prst="rect">
             <a:avLst/>
@@ -5107,8 +5030,8 @@
         </p:nvSpPr>
         <p:spPr>
           <a:xfrm>
-            <a:off x="6355080" y="4636008"/>
-            <a:ext cx="731520" cy="347472"/>
+            <a:off x="6355080" y="4334256"/>
+            <a:ext cx="731520" cy="310896"/>
           </a:xfrm>
           <a:prstGeom prst="rect">
             <a:avLst/>
@@ -5146,8 +5069,8 @@
         </p:nvSpPr>
         <p:spPr>
           <a:xfrm>
-            <a:off x="7059168" y="4636008"/>
-            <a:ext cx="731520" cy="347472"/>
+            <a:off x="7059168" y="4334256"/>
+            <a:ext cx="731520" cy="310896"/>
           </a:xfrm>
           <a:prstGeom prst="rect">
             <a:avLst/>
@@ -5185,8 +5108,8 @@
         </p:nvSpPr>
         <p:spPr>
           <a:xfrm>
-            <a:off x="4498848" y="5029200"/>
-            <a:ext cx="3291840" cy="365760"/>
+            <a:off x="4498848" y="4663440"/>
+            <a:ext cx="3291840" cy="320040"/>
           </a:xfrm>
           <a:prstGeom prst="rect">
             <a:avLst/>
@@ -5225,11 +5148,11 @@
         <p:spPr>
           <a:xfrm>
             <a:off x="8092440" y="1572768"/>
-            <a:ext cx="3566160" cy="3931920"/>
+            <a:ext cx="3566160" cy="3456432"/>
           </a:xfrm>
           <a:prstGeom prst="roundRect">
             <a:avLst>
-              <a:gd name="adj" fmla="val 2564"/>
+              <a:gd name="adj" fmla="val 2646"/>
             </a:avLst>
           </a:prstGeom>
           <a:solidFill>
@@ -5344,7 +5267,7 @@
         </p:nvSpPr>
         <p:spPr>
           <a:xfrm>
-            <a:off x="8247888" y="2121408"/>
+            <a:off x="8247888" y="2103120"/>
             <a:ext cx="3291840" cy="457200"/>
           </a:xfrm>
           <a:prstGeom prst="rect">
@@ -5400,7 +5323,7 @@
         </p:nvSpPr>
         <p:spPr>
           <a:xfrm>
-            <a:off x="8247888" y="2596896"/>
+            <a:off x="8247888" y="2532888"/>
             <a:ext cx="3291840" cy="457200"/>
           </a:xfrm>
           <a:prstGeom prst="rect">
@@ -5456,7 +5379,7 @@
         </p:nvSpPr>
         <p:spPr>
           <a:xfrm>
-            <a:off x="8247888" y="3072384"/>
+            <a:off x="8247888" y="2962656"/>
             <a:ext cx="3291840" cy="457200"/>
           </a:xfrm>
           <a:prstGeom prst="rect">
@@ -5512,7 +5435,7 @@
         </p:nvSpPr>
         <p:spPr>
           <a:xfrm>
-            <a:off x="8247888" y="3547872"/>
+            <a:off x="8247888" y="3392424"/>
             <a:ext cx="3291840" cy="457200"/>
           </a:xfrm>
           <a:prstGeom prst="rect">
@@ -5568,47 +5491,47 @@
         </p:nvSpPr>
         <p:spPr>
           <a:xfrm>
+            <a:off x="8247888" y="3840480"/>
+            <a:ext cx="2743200" cy="228600"/>
+          </a:xfrm>
+          <a:prstGeom prst="rect">
+            <a:avLst/>
+          </a:prstGeom>
+          <a:noFill/>
+          <a:ln/>
+        </p:spPr>
+        <p:txBody>
+          <a:bodyPr wrap="square" lIns="0" tIns="0" rIns="0" bIns="0" rtlCol="0" anchor="t"/>
+          <a:lstStyle/>
+          <a:p>
+            <a:pPr indent="0" marL="0">
+              <a:buNone/>
+            </a:pPr>
+            <a:r>
+              <a:rPr lang="en-US" sz="900" b="1" spc="100" kern="0" dirty="0">
+                <a:solidFill>
+                  <a:srgbClr val="F4A300"/>
+                </a:solidFill>
+                <a:latin typeface="Calibri" pitchFamily="34" charset="0"/>
+                <a:ea typeface="Calibri" pitchFamily="34" charset="-122"/>
+                <a:cs typeface="Calibri" pitchFamily="34" charset="-120"/>
+              </a:rPr>
+              <a:t>ASSUMPTIONS</a:t>
+            </a:r>
+            <a:endParaRPr lang="en-US" sz="900" dirty="0"/>
+          </a:p>
+        </p:txBody>
+      </p:sp>
+      <p:sp>
+        <p:nvSpPr>
+          <p:cNvPr id="70" name="Text 68"/>
+          <p:cNvSpPr txBox="1"/>
+          <p:nvPr/>
+        </p:nvSpPr>
+        <p:spPr>
+          <a:xfrm>
             <a:off x="8247888" y="4069080"/>
-            <a:ext cx="2743200" cy="228600"/>
-          </a:xfrm>
-          <a:prstGeom prst="rect">
-            <a:avLst/>
-          </a:prstGeom>
-          <a:noFill/>
-          <a:ln/>
-        </p:spPr>
-        <p:txBody>
-          <a:bodyPr wrap="square" lIns="0" tIns="0" rIns="0" bIns="0" rtlCol="0" anchor="t"/>
-          <a:lstStyle/>
-          <a:p>
-            <a:pPr indent="0" marL="0">
-              <a:buNone/>
-            </a:pPr>
-            <a:r>
-              <a:rPr lang="en-US" sz="900" b="1" spc="100" kern="0" dirty="0">
-                <a:solidFill>
-                  <a:srgbClr val="F4A300"/>
-                </a:solidFill>
-                <a:latin typeface="Calibri" pitchFamily="34" charset="0"/>
-                <a:ea typeface="Calibri" pitchFamily="34" charset="-122"/>
-                <a:cs typeface="Calibri" pitchFamily="34" charset="-120"/>
-              </a:rPr>
-              <a:t>ASSUMPTIONS</a:t>
-            </a:r>
-            <a:endParaRPr lang="en-US" sz="900" dirty="0"/>
-          </a:p>
-        </p:txBody>
-      </p:sp>
-      <p:sp>
-        <p:nvSpPr>
-          <p:cNvPr id="70" name="Text 68"/>
-          <p:cNvSpPr txBox="1"/>
-          <p:nvPr/>
-        </p:nvSpPr>
-        <p:spPr>
-          <a:xfrm>
-            <a:off x="8247888" y="4315968"/>
-            <a:ext cx="3291840" cy="1097280"/>
+            <a:ext cx="3291840" cy="914400"/>
           </a:xfrm>
           <a:prstGeom prst="rect">
             <a:avLst/>
@@ -5692,12 +5615,12 @@
         </p:nvSpPr>
         <p:spPr>
           <a:xfrm>
-            <a:off x="548640" y="5623560"/>
-            <a:ext cx="11109960" cy="566928"/>
+            <a:off x="548640" y="5166360"/>
+            <a:ext cx="11109960" cy="1051560"/>
           </a:xfrm>
           <a:prstGeom prst="roundRect">
             <a:avLst>
-              <a:gd name="adj" fmla="val 16129"/>
+              <a:gd name="adj" fmla="val 8696"/>
             </a:avLst>
           </a:prstGeom>
           <a:solidFill>
@@ -5726,8 +5649,86 @@
         </p:nvSpPr>
         <p:spPr>
           <a:xfrm>
-            <a:off x="777240" y="5623560"/>
-            <a:ext cx="10698480" cy="566928"/>
+            <a:off x="777240" y="5230368"/>
+            <a:ext cx="2743200" cy="237744"/>
+          </a:xfrm>
+          <a:prstGeom prst="rect">
+            <a:avLst/>
+          </a:prstGeom>
+          <a:noFill/>
+          <a:ln/>
+        </p:spPr>
+        <p:txBody>
+          <a:bodyPr wrap="square" lIns="0" tIns="0" rIns="0" bIns="0" rtlCol="0" anchor="t"/>
+          <a:lstStyle/>
+          <a:p>
+            <a:pPr indent="0" marL="0">
+              <a:buNone/>
+            </a:pPr>
+            <a:r>
+              <a:rPr lang="en-US" sz="1050" b="1" spc="100" kern="0" dirty="0">
+                <a:solidFill>
+                  <a:srgbClr val="F4A300"/>
+                </a:solidFill>
+                <a:latin typeface="Calibri" pitchFamily="34" charset="0"/>
+                <a:ea typeface="Calibri" pitchFamily="34" charset="-122"/>
+                <a:cs typeface="Calibri" pitchFamily="34" charset="-120"/>
+              </a:rPr>
+              <a:t>RETURN ON INVESTMENT</a:t>
+            </a:r>
+            <a:endParaRPr lang="en-US" sz="1050" dirty="0"/>
+          </a:p>
+        </p:txBody>
+      </p:sp>
+      <p:sp>
+        <p:nvSpPr>
+          <p:cNvPr id="73" name="Text 71"/>
+          <p:cNvSpPr txBox="1"/>
+          <p:nvPr/>
+        </p:nvSpPr>
+        <p:spPr>
+          <a:xfrm>
+            <a:off x="3291840" y="5230368"/>
+            <a:ext cx="8138160" cy="237744"/>
+          </a:xfrm>
+          <a:prstGeom prst="rect">
+            <a:avLst/>
+          </a:prstGeom>
+          <a:noFill/>
+          <a:ln/>
+        </p:spPr>
+        <p:txBody>
+          <a:bodyPr wrap="square" lIns="0" tIns="0" rIns="0" bIns="0" rtlCol="0" anchor="t"/>
+          <a:lstStyle/>
+          <a:p>
+            <a:pPr algn="r" indent="0" marL="0">
+              <a:buNone/>
+            </a:pPr>
+            <a:r>
+              <a:rPr lang="en-US" sz="900" i="1" dirty="0">
+                <a:solidFill>
+                  <a:srgbClr val="8FA0BF"/>
+                </a:solidFill>
+                <a:latin typeface="Calibri" pitchFamily="34" charset="0"/>
+                <a:ea typeface="Calibri" pitchFamily="34" charset="-122"/>
+                <a:cs typeface="Calibri" pitchFamily="34" charset="-120"/>
+              </a:rPr>
+              <a:t>illustrative · built on the deck's pricing assumptions · validated in the pilot</a:t>
+            </a:r>
+            <a:endParaRPr lang="en-US" sz="900" dirty="0"/>
+          </a:p>
+        </p:txBody>
+      </p:sp>
+      <p:sp>
+        <p:nvSpPr>
+          <p:cNvPr id="74" name="Text 72"/>
+          <p:cNvSpPr txBox="1"/>
+          <p:nvPr/>
+        </p:nvSpPr>
+        <p:spPr>
+          <a:xfrm>
+            <a:off x="777240" y="5486400"/>
+            <a:ext cx="1234440" cy="658368"/>
           </a:xfrm>
           <a:prstGeom prst="rect">
             <a:avLst/>
@@ -5739,11 +5740,50 @@
           <a:bodyPr wrap="square" lIns="0" tIns="0" rIns="0" bIns="0" rtlCol="0" anchor="ctr"/>
           <a:lstStyle/>
           <a:p>
-            <a:pPr algn="ctr" indent="0" marL="0">
-              <a:buNone/>
-            </a:pPr>
-            <a:r>
-              <a:rPr lang="en-US" sz="1400" b="1" dirty="0">
+            <a:pPr indent="0" marL="0">
+              <a:buNone/>
+            </a:pPr>
+            <a:r>
+              <a:rPr lang="en-US" sz="2200" b="1" dirty="0">
+                <a:solidFill>
+                  <a:srgbClr val="F4A300"/>
+                </a:solidFill>
+                <a:latin typeface="Cambria" pitchFamily="34" charset="0"/>
+                <a:ea typeface="Cambria" pitchFamily="34" charset="-122"/>
+                <a:cs typeface="Cambria" pitchFamily="34" charset="-120"/>
+              </a:rPr>
+              <a:t>~2.3×</a:t>
+            </a:r>
+            <a:endParaRPr lang="en-US" sz="2200" dirty="0"/>
+          </a:p>
+        </p:txBody>
+      </p:sp>
+      <p:sp>
+        <p:nvSpPr>
+          <p:cNvPr id="75" name="Text 73"/>
+          <p:cNvSpPr txBox="1"/>
+          <p:nvPr/>
+        </p:nvSpPr>
+        <p:spPr>
+          <a:xfrm>
+            <a:off x="2039112" y="5486400"/>
+            <a:ext cx="1417320" cy="658368"/>
+          </a:xfrm>
+          <a:prstGeom prst="rect">
+            <a:avLst/>
+          </a:prstGeom>
+          <a:noFill/>
+          <a:ln/>
+        </p:spPr>
+        <p:txBody>
+          <a:bodyPr wrap="square" lIns="0" tIns="0" rIns="0" bIns="0" rtlCol="0" anchor="ctr"/>
+          <a:lstStyle/>
+          <a:p>
+            <a:pPr indent="0" marL="0">
+              <a:buNone/>
+            </a:pPr>
+            <a:r>
+              <a:rPr lang="en-US" sz="950" b="1" dirty="0">
                 <a:solidFill>
                   <a:srgbClr val="FFFFFF"/>
                 </a:solidFill>
@@ -5751,13 +5791,16 @@
                 <a:ea typeface="Calibri" pitchFamily="34" charset="-122"/>
                 <a:cs typeface="Calibri" pitchFamily="34" charset="-120"/>
               </a:rPr>
-              <a:t>“Don't cancel” should mean don't cancel.</a:t>
-            </a:r>
-            <a:pPr algn="ctr" indent="0" marL="0">
-              <a:buNone/>
-            </a:pPr>
-            <a:r>
-              <a:rPr lang="en-US" sz="1400" dirty="0">
+              <a:t>Customer ROI</a:t>
+            </a:r>
+            <a:endParaRPr lang="en-US" sz="950" dirty="0"/>
+          </a:p>
+          <a:p>
+            <a:pPr indent="0" marL="0">
+              <a:buNone/>
+            </a:pPr>
+            <a:r>
+              <a:rPr lang="en-US" sz="950" dirty="0">
                 <a:solidFill>
                   <a:srgbClr val="CADCFC"/>
                 </a:solidFill>
@@ -5765,15 +5808,300 @@
                 <a:ea typeface="Calibri" pitchFamily="34" charset="-122"/>
                 <a:cs typeface="Calibri" pitchFamily="34" charset="-120"/>
               </a:rPr>
-              <a:t>   Codemix Skill  ·  Understand → Decide → Act → Audit</a:t>
-            </a:r>
-            <a:endParaRPr lang="en-US" sz="1400" dirty="0"/>
-          </a:p>
-        </p:txBody>
-      </p:sp>
-      <p:sp>
-        <p:nvSpPr>
-          <p:cNvPr id="73" name="Text 71"/>
+              <a:t>₹20K saved vs ₹8.5K fee per month</a:t>
+            </a:r>
+            <a:endParaRPr lang="en-US" sz="950" dirty="0"/>
+          </a:p>
+        </p:txBody>
+      </p:sp>
+      <p:sp>
+        <p:nvSpPr>
+          <p:cNvPr id="76" name="Text 74"/>
+          <p:cNvSpPr txBox="1"/>
+          <p:nvPr/>
+        </p:nvSpPr>
+        <p:spPr>
+          <a:xfrm>
+            <a:off x="3520440" y="5486400"/>
+            <a:ext cx="1234440" cy="658368"/>
+          </a:xfrm>
+          <a:prstGeom prst="rect">
+            <a:avLst/>
+          </a:prstGeom>
+          <a:noFill/>
+          <a:ln/>
+        </p:spPr>
+        <p:txBody>
+          <a:bodyPr wrap="square" lIns="0" tIns="0" rIns="0" bIns="0" rtlCol="0" anchor="ctr"/>
+          <a:lstStyle/>
+          <a:p>
+            <a:pPr indent="0" marL="0">
+              <a:buNone/>
+            </a:pPr>
+            <a:r>
+              <a:rPr lang="en-US" sz="2200" b="1" dirty="0">
+                <a:solidFill>
+                  <a:srgbClr val="F4A300"/>
+                </a:solidFill>
+                <a:latin typeface="Cambria" pitchFamily="34" charset="0"/>
+                <a:ea typeface="Cambria" pitchFamily="34" charset="-122"/>
+                <a:cs typeface="Cambria" pitchFamily="34" charset="-120"/>
+              </a:rPr>
+              <a:t>9</a:t>
+            </a:r>
+            <a:endParaRPr lang="en-US" sz="2200" dirty="0"/>
+          </a:p>
+        </p:txBody>
+      </p:sp>
+      <p:sp>
+        <p:nvSpPr>
+          <p:cNvPr id="77" name="Text 75"/>
+          <p:cNvSpPr txBox="1"/>
+          <p:nvPr/>
+        </p:nvSpPr>
+        <p:spPr>
+          <a:xfrm>
+            <a:off x="4782312" y="5486400"/>
+            <a:ext cx="1417320" cy="658368"/>
+          </a:xfrm>
+          <a:prstGeom prst="rect">
+            <a:avLst/>
+          </a:prstGeom>
+          <a:noFill/>
+          <a:ln/>
+        </p:spPr>
+        <p:txBody>
+          <a:bodyPr wrap="square" lIns="0" tIns="0" rIns="0" bIns="0" rtlCol="0" anchor="ctr"/>
+          <a:lstStyle/>
+          <a:p>
+            <a:pPr indent="0" marL="0">
+              <a:buNone/>
+            </a:pPr>
+            <a:r>
+              <a:rPr lang="en-US" sz="950" b="1" dirty="0">
+                <a:solidFill>
+                  <a:srgbClr val="FFFFFF"/>
+                </a:solidFill>
+                <a:latin typeface="Calibri" pitchFamily="34" charset="0"/>
+                <a:ea typeface="Calibri" pitchFamily="34" charset="-122"/>
+                <a:cs typeface="Calibri" pitchFamily="34" charset="-120"/>
+              </a:rPr>
+              <a:t>Break-even</a:t>
+            </a:r>
+            <a:endParaRPr lang="en-US" sz="950" dirty="0"/>
+          </a:p>
+          <a:p>
+            <a:pPr indent="0" marL="0">
+              <a:buNone/>
+            </a:pPr>
+            <a:r>
+              <a:rPr lang="en-US" sz="950" dirty="0">
+                <a:solidFill>
+                  <a:srgbClr val="CADCFC"/>
+                </a:solidFill>
+                <a:latin typeface="Calibri" pitchFamily="34" charset="0"/>
+                <a:ea typeface="Calibri" pitchFamily="34" charset="-122"/>
+                <a:cs typeface="Calibri" pitchFamily="34" charset="-120"/>
+              </a:rPr>
+              <a:t>wrong ₹1,000 refunds prevented per month</a:t>
+            </a:r>
+            <a:endParaRPr lang="en-US" sz="950" dirty="0"/>
+          </a:p>
+        </p:txBody>
+      </p:sp>
+      <p:sp>
+        <p:nvSpPr>
+          <p:cNvPr id="78" name="Text 76"/>
+          <p:cNvSpPr txBox="1"/>
+          <p:nvPr/>
+        </p:nvSpPr>
+        <p:spPr>
+          <a:xfrm>
+            <a:off x="6263640" y="5486400"/>
+            <a:ext cx="1234440" cy="658368"/>
+          </a:xfrm>
+          <a:prstGeom prst="rect">
+            <a:avLst/>
+          </a:prstGeom>
+          <a:noFill/>
+          <a:ln/>
+        </p:spPr>
+        <p:txBody>
+          <a:bodyPr wrap="square" lIns="0" tIns="0" rIns="0" bIns="0" rtlCol="0" anchor="ctr"/>
+          <a:lstStyle/>
+          <a:p>
+            <a:pPr indent="0" marL="0">
+              <a:buNone/>
+            </a:pPr>
+            <a:r>
+              <a:rPr lang="en-US" sz="2200" b="1" dirty="0">
+                <a:solidFill>
+                  <a:srgbClr val="F4A300"/>
+                </a:solidFill>
+                <a:latin typeface="Cambria" pitchFamily="34" charset="0"/>
+                <a:ea typeface="Cambria" pitchFamily="34" charset="-122"/>
+                <a:cs typeface="Cambria" pitchFamily="34" charset="-120"/>
+              </a:rPr>
+              <a:t>~1.3×</a:t>
+            </a:r>
+            <a:endParaRPr lang="en-US" sz="2200" dirty="0"/>
+          </a:p>
+        </p:txBody>
+      </p:sp>
+      <p:sp>
+        <p:nvSpPr>
+          <p:cNvPr id="79" name="Text 77"/>
+          <p:cNvSpPr txBox="1"/>
+          <p:nvPr/>
+        </p:nvSpPr>
+        <p:spPr>
+          <a:xfrm>
+            <a:off x="7525512" y="5486400"/>
+            <a:ext cx="1417320" cy="658368"/>
+          </a:xfrm>
+          <a:prstGeom prst="rect">
+            <a:avLst/>
+          </a:prstGeom>
+          <a:noFill/>
+          <a:ln/>
+        </p:spPr>
+        <p:txBody>
+          <a:bodyPr wrap="square" lIns="0" tIns="0" rIns="0" bIns="0" rtlCol="0" anchor="ctr"/>
+          <a:lstStyle/>
+          <a:p>
+            <a:pPr indent="0" marL="0">
+              <a:buNone/>
+            </a:pPr>
+            <a:r>
+              <a:rPr lang="en-US" sz="950" b="1" dirty="0">
+                <a:solidFill>
+                  <a:srgbClr val="FFFFFF"/>
+                </a:solidFill>
+                <a:latin typeface="Calibri" pitchFamily="34" charset="0"/>
+                <a:ea typeface="Calibri" pitchFamily="34" charset="-122"/>
+                <a:cs typeface="Calibri" pitchFamily="34" charset="-120"/>
+              </a:rPr>
+              <a:t>Year-1 ROI (Freshworks)</a:t>
+            </a:r>
+            <a:endParaRPr lang="en-US" sz="950" dirty="0"/>
+          </a:p>
+          <a:p>
+            <a:pPr indent="0" marL="0">
+              <a:buNone/>
+            </a:pPr>
+            <a:r>
+              <a:rPr lang="en-US" sz="950" dirty="0">
+                <a:solidFill>
+                  <a:srgbClr val="CADCFC"/>
+                </a:solidFill>
+                <a:latin typeface="Calibri" pitchFamily="34" charset="0"/>
+                <a:ea typeface="Calibri" pitchFamily="34" charset="-122"/>
+                <a:cs typeface="Calibri" pitchFamily="34" charset="-120"/>
+              </a:rPr>
+              <a:t>~$120K ARR on a ~$90K build</a:t>
+            </a:r>
+            <a:endParaRPr lang="en-US" sz="950" dirty="0"/>
+          </a:p>
+        </p:txBody>
+      </p:sp>
+      <p:sp>
+        <p:nvSpPr>
+          <p:cNvPr id="80" name="Text 78"/>
+          <p:cNvSpPr txBox="1"/>
+          <p:nvPr/>
+        </p:nvSpPr>
+        <p:spPr>
+          <a:xfrm>
+            <a:off x="9006840" y="5486400"/>
+            <a:ext cx="1234440" cy="658368"/>
+          </a:xfrm>
+          <a:prstGeom prst="rect">
+            <a:avLst/>
+          </a:prstGeom>
+          <a:noFill/>
+          <a:ln/>
+        </p:spPr>
+        <p:txBody>
+          <a:bodyPr wrap="square" lIns="0" tIns="0" rIns="0" bIns="0" rtlCol="0" anchor="ctr"/>
+          <a:lstStyle/>
+          <a:p>
+            <a:pPr indent="0" marL="0">
+              <a:buNone/>
+            </a:pPr>
+            <a:r>
+              <a:rPr lang="en-US" sz="2200" b="1" dirty="0">
+                <a:solidFill>
+                  <a:srgbClr val="F4A300"/>
+                </a:solidFill>
+                <a:latin typeface="Cambria" pitchFamily="34" charset="0"/>
+                <a:ea typeface="Cambria" pitchFamily="34" charset="-122"/>
+                <a:cs typeface="Cambria" pitchFamily="34" charset="-120"/>
+              </a:rPr>
+              <a:t>~9 mo</a:t>
+            </a:r>
+            <a:endParaRPr lang="en-US" sz="2200" dirty="0"/>
+          </a:p>
+        </p:txBody>
+      </p:sp>
+      <p:sp>
+        <p:nvSpPr>
+          <p:cNvPr id="81" name="Text 79"/>
+          <p:cNvSpPr txBox="1"/>
+          <p:nvPr/>
+        </p:nvSpPr>
+        <p:spPr>
+          <a:xfrm>
+            <a:off x="10268712" y="5486400"/>
+            <a:ext cx="1417320" cy="658368"/>
+          </a:xfrm>
+          <a:prstGeom prst="rect">
+            <a:avLst/>
+          </a:prstGeom>
+          <a:noFill/>
+          <a:ln/>
+        </p:spPr>
+        <p:txBody>
+          <a:bodyPr wrap="square" lIns="0" tIns="0" rIns="0" bIns="0" rtlCol="0" anchor="ctr"/>
+          <a:lstStyle/>
+          <a:p>
+            <a:pPr indent="0" marL="0">
+              <a:buNone/>
+            </a:pPr>
+            <a:r>
+              <a:rPr lang="en-US" sz="950" b="1" dirty="0">
+                <a:solidFill>
+                  <a:srgbClr val="FFFFFF"/>
+                </a:solidFill>
+                <a:latin typeface="Calibri" pitchFamily="34" charset="0"/>
+                <a:ea typeface="Calibri" pitchFamily="34" charset="-122"/>
+                <a:cs typeface="Calibri" pitchFamily="34" charset="-120"/>
+              </a:rPr>
+              <a:t>Payback</a:t>
+            </a:r>
+            <a:endParaRPr lang="en-US" sz="950" dirty="0"/>
+          </a:p>
+          <a:p>
+            <a:pPr indent="0" marL="0">
+              <a:buNone/>
+            </a:pPr>
+            <a:r>
+              <a:rPr lang="en-US" sz="950" dirty="0">
+                <a:solidFill>
+                  <a:srgbClr val="CADCFC"/>
+                </a:solidFill>
+                <a:latin typeface="Calibri" pitchFamily="34" charset="0"/>
+                <a:ea typeface="Calibri" pitchFamily="34" charset="-122"/>
+                <a:cs typeface="Calibri" pitchFamily="34" charset="-120"/>
+              </a:rPr>
+              <a:t>at ~$10K MRR</a:t>
+            </a:r>
+            <a:endParaRPr lang="en-US" sz="950" dirty="0"/>
+          </a:p>
+        </p:txBody>
+      </p:sp>
+      <p:sp>
+        <p:nvSpPr>
+          <p:cNvPr id="82" name="Text 80"/>
           <p:cNvSpPr txBox="1"/>
           <p:nvPr/>
         </p:nvSpPr>
@@ -19212,7 +19540,7 @@
                 <a:ea typeface="Calibri" pitchFamily="34" charset="-122"/>
                 <a:cs typeface="Calibri" pitchFamily="34" charset="-120"/>
               </a:rPr>
-              <a:t>Only sensitive actions are metered: one prevented ₹1,000 wrong refund pays for 2,000+ guarded actions.</a:t>
+              <a:t>Only sensitive actions are metered: one prevented ₹1,000 wrong refund pays for 2,000+ guarded actions (~2.3× customer ROI, slide 10).</a:t>
             </a:r>
             <a:endParaRPr lang="en-US" sz="1000" dirty="0"/>
           </a:p>

</xml_diff>

<commit_message>
docs: re-price on real unit economics and rebuild ROI in 10-slide deck
Prices now sit above each integration's run cost (VoBiz, Sarvam,
ElevenLabs, Claude, hosting): $0.03 per guarded action for the plug-in
and Rs 8/min for the full voice agent, ~55% gross margin. Year-1
revenue $349K vs $90K build, ~8-month payback, ~3.8x customer ROI;
full assumptions in speaker notes.

Co-Authored-By: Claude Opus 5.5 <noreply@anthropic.com>
Claude-Session: https://claude.ai/code/session_012DT45KpxUQbVV43mbMd9KB
</commit_message>
<xml_diff>
--- a/docs/presentation/CodemixSkill-Final-10-Slides.pptx
+++ b/docs/presentation/CodemixSkill-Final-10-Slides.pptx
@@ -932,7 +932,7 @@
           <a:p>
             <a:r>
               <a:rPr lang="en-US" dirty="0"/>
-              <a:t/>
+              <a:t>ROI assumptions. Unit costs (Sep 2026 list prices, ₹85/$): VoBiz ₹0.45/min; Sarvam STT ₹30/hr; ElevenLabs Flash $0.05 per 1K chars (~1,500 agent chars per 3-min call); Claude checks ~2 per call, Haiku 4.5 ($1/$5 per M tokens) for routine and Sonnet 5 ($2/$10) for ~20% ambiguous cases, ~2K in / 300 out tokens each; hosting + storage ~$0.005. Voice call cost ~₹10.4 per 3 min (~₹3.5/min) vs ₹8/min price (~56% margin). Plug-in cost ~₹1.1 per guarded action vs $0.03 (₹2.55) price (~55% margin). Dodo Payments fees (4% + $0.15 per INR transaction, $1 per refund) and Freshdesk plans are paid by the customer on their own accounts. Year 1: plug-in ramps to 50 customers (avg 25) at 20K guarded actions/month = $180K; voice ramps to 10 brands (avg 5) at 30K minutes/month = $169K; total $349K revenue, ~$195K gross profit; cumulative gross profit passes the $90K build around month 8. Customer ROI: brand with 20K guarded actions pays $600 (₹51K)/month; if 2% of requests contain a negation and 48% of those misfire (our measured rate), ~192 wrong ₹1,000 actions are prevented = ₹1.92L/month, ~3.8x; break-even at 51 prevented actions = 0.26%.</a:t>
             </a:r>
             <a:endParaRPr lang="en-US" dirty="0"/>
           </a:p>
@@ -3126,7 +3126,7 @@
                 <a:ea typeface="Calibri" pitchFamily="34" charset="-122"/>
                 <a:cs typeface="Calibri" pitchFamily="34" charset="-120"/>
               </a:rPr>
-              <a:t>What it costs, what it returns, how we measure it, and what could go wrong</a:t>
+              <a:t>What it costs to build and run, what it returns, how we measure it, and what could go wrong</a:t>
             </a:r>
             <a:endParaRPr lang="en-US" sz="1350" dirty="0"/>
           </a:p>
@@ -3246,7 +3246,7 @@
                 <a:ea typeface="Cambria" pitchFamily="34" charset="-122"/>
                 <a:cs typeface="Cambria" pitchFamily="34" charset="-120"/>
               </a:rPr>
-              <a:t>Costs &amp; Resources</a:t>
+              <a:t>Costs &amp; Unit Economics</a:t>
             </a:r>
             <a:endParaRPr lang="en-US" sz="1400" dirty="0"/>
           </a:p>
@@ -3260,8 +3260,8 @@
         </p:nvSpPr>
         <p:spPr>
           <a:xfrm>
-            <a:off x="731520" y="2103120"/>
-            <a:ext cx="1828800" cy="502920"/>
+            <a:off x="731520" y="2084832"/>
+            <a:ext cx="1600200" cy="457200"/>
           </a:xfrm>
           <a:prstGeom prst="rect">
             <a:avLst/>
@@ -3277,7 +3277,7 @@
               <a:buNone/>
             </a:pPr>
             <a:r>
-              <a:rPr lang="en-US" sz="2600" b="1" dirty="0">
+              <a:rPr lang="en-US" sz="2400" b="1" dirty="0">
                 <a:solidFill>
                   <a:srgbClr val="14213D"/>
                 </a:solidFill>
@@ -3287,7 +3287,7 @@
               </a:rPr>
               <a:t>~$90K</a:t>
             </a:r>
-            <a:endParaRPr lang="en-US" sz="2600" dirty="0"/>
+            <a:endParaRPr lang="en-US" sz="2400" dirty="0"/>
           </a:p>
         </p:txBody>
       </p:sp>
@@ -3299,8 +3299,8 @@
         </p:nvSpPr>
         <p:spPr>
           <a:xfrm>
-            <a:off x="2377440" y="2103120"/>
-            <a:ext cx="1737360" cy="502920"/>
+            <a:off x="2286000" y="2084832"/>
+            <a:ext cx="1828800" cy="457200"/>
           </a:xfrm>
           <a:prstGeom prst="rect">
             <a:avLst/>
@@ -3316,7 +3316,7 @@
               <a:buNone/>
             </a:pPr>
             <a:r>
-              <a:rPr lang="en-US" sz="1050" dirty="0">
+              <a:rPr lang="en-US" sz="850" dirty="0">
                 <a:solidFill>
                   <a:srgbClr val="5B6475"/>
                 </a:solidFill>
@@ -3324,9 +3324,9 @@
                 <a:ea typeface="Calibri" pitchFamily="34" charset="-122"/>
                 <a:cs typeface="Calibri" pitchFamily="34" charset="-120"/>
               </a:rPr>
-              <a:t>3-month MVP (estimate)</a:t>
-            </a:r>
-            <a:endParaRPr lang="en-US" sz="1050" dirty="0"/>
+              <a:t>3-month MVP build: M1 data · M2 gate + voice · M3 Freshdesk + pilot</a:t>
+            </a:r>
+            <a:endParaRPr lang="en-US" sz="850" dirty="0"/>
           </a:p>
         </p:txBody>
       </p:sp>
@@ -3338,8 +3338,8 @@
         </p:nvSpPr>
         <p:spPr>
           <a:xfrm>
-            <a:off x="731520" y="2697480"/>
-            <a:ext cx="1508760" cy="274320"/>
+            <a:off x="731520" y="2542032"/>
+            <a:ext cx="3337560" cy="329184"/>
           </a:xfrm>
           <a:prstGeom prst="rect">
             <a:avLst/>
@@ -3355,7 +3355,7 @@
               <a:buNone/>
             </a:pPr>
             <a:r>
-              <a:rPr lang="en-US" sz="1050" dirty="0">
+              <a:rPr lang="en-US" sz="850" dirty="0">
                 <a:solidFill>
                   <a:srgbClr val="1F2937"/>
                 </a:solidFill>
@@ -3363,34 +3363,71 @@
                 <a:ea typeface="Calibri" pitchFamily="34" charset="-122"/>
                 <a:cs typeface="Calibri" pitchFamily="34" charset="-120"/>
               </a:rPr>
-              <a:t>3 engineers</a:t>
-            </a:r>
-            <a:endParaRPr lang="en-US" sz="1050" dirty="0"/>
-          </a:p>
-        </p:txBody>
-      </p:sp>
-      <p:sp>
-        <p:nvSpPr>
-          <p:cNvPr id="13" name="Shape 11"/>
+              <a:t>Engineers $60K · linguist $10K · PM $8K · APIs $7K · buffer $5K</a:t>
+            </a:r>
+            <a:endParaRPr lang="en-US" sz="850" dirty="0"/>
+          </a:p>
+        </p:txBody>
+      </p:sp>
+      <p:sp>
+        <p:nvSpPr>
+          <p:cNvPr id="13" name="Text 11"/>
+          <p:cNvSpPr txBox="1"/>
+          <p:nvPr/>
+        </p:nvSpPr>
+        <p:spPr>
+          <a:xfrm>
+            <a:off x="731520" y="2907792"/>
+            <a:ext cx="3291840" cy="228600"/>
+          </a:xfrm>
+          <a:prstGeom prst="rect">
+            <a:avLst/>
+          </a:prstGeom>
+          <a:noFill/>
+          <a:ln/>
+        </p:spPr>
+        <p:txBody>
+          <a:bodyPr wrap="square" lIns="0" tIns="0" rIns="0" bIns="0" rtlCol="0" anchor="t"/>
+          <a:lstStyle/>
+          <a:p>
+            <a:pPr indent="0" marL="0">
+              <a:buNone/>
+            </a:pPr>
+            <a:r>
+              <a:rPr lang="en-US" sz="900" b="1" spc="100" kern="0" dirty="0">
+                <a:solidFill>
+                  <a:srgbClr val="F4A300"/>
+                </a:solidFill>
+                <a:latin typeface="Calibri" pitchFamily="34" charset="0"/>
+                <a:ea typeface="Calibri" pitchFamily="34" charset="-122"/>
+                <a:cs typeface="Calibri" pitchFamily="34" charset="-120"/>
+              </a:rPr>
+              <a:t>RUN COST PER 3-MIN VOICE CALL</a:t>
+            </a:r>
+            <a:endParaRPr lang="en-US" sz="900" dirty="0"/>
+          </a:p>
+        </p:txBody>
+      </p:sp>
+      <p:sp>
+        <p:nvSpPr>
+          <p:cNvPr id="14" name="Shape 12"/>
           <p:cNvSpPr/>
           <p:nvPr/>
         </p:nvSpPr>
         <p:spPr>
           <a:xfrm>
-            <a:off x="2240280" y="2743200"/>
-            <a:ext cx="1234440" cy="182880"/>
-          </a:xfrm>
-          <a:prstGeom prst="roundRect">
-            <a:avLst>
-              <a:gd name="adj" fmla="val 25000"/>
-            </a:avLst>
+            <a:off x="658368" y="3145536"/>
+            <a:ext cx="3383280" cy="228600"/>
+          </a:xfrm>
+          <a:prstGeom prst="rect">
+            <a:avLst/>
           </a:prstGeom>
           <a:solidFill>
-            <a:srgbClr val="14213D"/>
+            <a:srgbClr val="F4F6F9"/>
           </a:solidFill>
           <a:ln w="12700">
             <a:solidFill>
-              <a:srgbClr val="14213D"/>
+              <a:srgbClr val="F4F6F9"/>
             </a:solidFill>
             <a:prstDash val="solid"/>
           </a:ln>
@@ -3398,14 +3435,14 @@
       </p:sp>
       <p:sp>
         <p:nvSpPr>
-          <p:cNvPr id="14" name="Text 12"/>
-          <p:cNvSpPr txBox="1"/>
-          <p:nvPr/>
-        </p:nvSpPr>
-        <p:spPr>
-          <a:xfrm>
-            <a:off x="3520440" y="2697480"/>
-            <a:ext cx="548640" cy="274320"/>
+          <p:cNvPr id="15" name="Text 13"/>
+          <p:cNvSpPr txBox="1"/>
+          <p:nvPr/>
+        </p:nvSpPr>
+        <p:spPr>
+          <a:xfrm>
+            <a:off x="731520" y="3145536"/>
+            <a:ext cx="2651760" cy="228600"/>
           </a:xfrm>
           <a:prstGeom prst="rect">
             <a:avLst/>
@@ -3421,7 +3458,46 @@
               <a:buNone/>
             </a:pPr>
             <a:r>
-              <a:rPr lang="en-US" sz="1000" b="1" dirty="0">
+              <a:rPr lang="en-US" sz="900" dirty="0">
+                <a:solidFill>
+                  <a:srgbClr val="1F2937"/>
+                </a:solidFill>
+                <a:latin typeface="Calibri" pitchFamily="34" charset="0"/>
+                <a:ea typeface="Calibri" pitchFamily="34" charset="-122"/>
+                <a:cs typeface="Calibri" pitchFamily="34" charset="-120"/>
+              </a:rPr>
+              <a:t>VoBiz telephony (₹0.45/min)</a:t>
+            </a:r>
+            <a:endParaRPr lang="en-US" sz="900" dirty="0"/>
+          </a:p>
+        </p:txBody>
+      </p:sp>
+      <p:sp>
+        <p:nvSpPr>
+          <p:cNvPr id="16" name="Text 14"/>
+          <p:cNvSpPr txBox="1"/>
+          <p:nvPr/>
+        </p:nvSpPr>
+        <p:spPr>
+          <a:xfrm>
+            <a:off x="3337560" y="3145536"/>
+            <a:ext cx="658368" cy="228600"/>
+          </a:xfrm>
+          <a:prstGeom prst="rect">
+            <a:avLst/>
+          </a:prstGeom>
+          <a:noFill/>
+          <a:ln/>
+        </p:spPr>
+        <p:txBody>
+          <a:bodyPr wrap="square" lIns="0" tIns="0" rIns="0" bIns="0" rtlCol="0" anchor="ctr"/>
+          <a:lstStyle/>
+          <a:p>
+            <a:pPr algn="r" indent="0" marL="0">
+              <a:buNone/>
+            </a:pPr>
+            <a:r>
+              <a:rPr lang="en-US" sz="900" b="1" dirty="0">
                 <a:solidFill>
                   <a:srgbClr val="14213D"/>
                 </a:solidFill>
@@ -3429,73 +3505,32 @@
                 <a:ea typeface="Calibri" pitchFamily="34" charset="-122"/>
                 <a:cs typeface="Calibri" pitchFamily="34" charset="-120"/>
               </a:rPr>
-              <a:t>$60K</a:t>
-            </a:r>
-            <a:endParaRPr lang="en-US" sz="1000" dirty="0"/>
-          </a:p>
-        </p:txBody>
-      </p:sp>
-      <p:sp>
-        <p:nvSpPr>
-          <p:cNvPr id="15" name="Text 13"/>
-          <p:cNvSpPr txBox="1"/>
-          <p:nvPr/>
-        </p:nvSpPr>
-        <p:spPr>
-          <a:xfrm>
-            <a:off x="731520" y="3026664"/>
-            <a:ext cx="1508760" cy="274320"/>
-          </a:xfrm>
-          <a:prstGeom prst="rect">
-            <a:avLst/>
-          </a:prstGeom>
-          <a:noFill/>
-          <a:ln/>
-        </p:spPr>
-        <p:txBody>
-          <a:bodyPr wrap="square" lIns="0" tIns="0" rIns="0" bIns="0" rtlCol="0" anchor="ctr"/>
-          <a:lstStyle/>
-          <a:p>
-            <a:pPr indent="0" marL="0">
-              <a:buNone/>
-            </a:pPr>
-            <a:r>
-              <a:rPr lang="en-US" sz="1050" dirty="0">
-                <a:solidFill>
-                  <a:srgbClr val="1F2937"/>
-                </a:solidFill>
-                <a:latin typeface="Calibri" pitchFamily="34" charset="0"/>
-                <a:ea typeface="Calibri" pitchFamily="34" charset="-122"/>
-                <a:cs typeface="Calibri" pitchFamily="34" charset="-120"/>
-              </a:rPr>
-              <a:t>Linguist + labelling</a:t>
-            </a:r>
-            <a:endParaRPr lang="en-US" sz="1050" dirty="0"/>
-          </a:p>
-        </p:txBody>
-      </p:sp>
-      <p:sp>
-        <p:nvSpPr>
-          <p:cNvPr id="16" name="Shape 14"/>
+              <a:t>₹1.35</a:t>
+            </a:r>
+            <a:endParaRPr lang="en-US" sz="900" dirty="0"/>
+          </a:p>
+        </p:txBody>
+      </p:sp>
+      <p:sp>
+        <p:nvSpPr>
+          <p:cNvPr id="17" name="Shape 15"/>
           <p:cNvSpPr/>
           <p:nvPr/>
         </p:nvSpPr>
         <p:spPr>
           <a:xfrm>
-            <a:off x="2240280" y="3072384"/>
-            <a:ext cx="205740" cy="182880"/>
-          </a:xfrm>
-          <a:prstGeom prst="roundRect">
-            <a:avLst>
-              <a:gd name="adj" fmla="val 25000"/>
-            </a:avLst>
+            <a:off x="658368" y="3383280"/>
+            <a:ext cx="3383280" cy="228600"/>
+          </a:xfrm>
+          <a:prstGeom prst="rect">
+            <a:avLst/>
           </a:prstGeom>
           <a:solidFill>
-            <a:srgbClr val="2A5C8A"/>
+            <a:srgbClr val="FFFFFF"/>
           </a:solidFill>
           <a:ln w="12700">
             <a:solidFill>
-              <a:srgbClr val="2A5C8A"/>
+              <a:srgbClr val="FFFFFF"/>
             </a:solidFill>
             <a:prstDash val="solid"/>
           </a:ln>
@@ -3503,14 +3538,14 @@
       </p:sp>
       <p:sp>
         <p:nvSpPr>
-          <p:cNvPr id="17" name="Text 15"/>
-          <p:cNvSpPr txBox="1"/>
-          <p:nvPr/>
-        </p:nvSpPr>
-        <p:spPr>
-          <a:xfrm>
-            <a:off x="2491740" y="3026664"/>
-            <a:ext cx="548640" cy="274320"/>
+          <p:cNvPr id="18" name="Text 16"/>
+          <p:cNvSpPr txBox="1"/>
+          <p:nvPr/>
+        </p:nvSpPr>
+        <p:spPr>
+          <a:xfrm>
+            <a:off x="731520" y="3383280"/>
+            <a:ext cx="2651760" cy="228600"/>
           </a:xfrm>
           <a:prstGeom prst="rect">
             <a:avLst/>
@@ -3526,7 +3561,46 @@
               <a:buNone/>
             </a:pPr>
             <a:r>
-              <a:rPr lang="en-US" sz="1000" b="1" dirty="0">
+              <a:rPr lang="en-US" sz="900" dirty="0">
+                <a:solidFill>
+                  <a:srgbClr val="1F2937"/>
+                </a:solidFill>
+                <a:latin typeface="Calibri" pitchFamily="34" charset="0"/>
+                <a:ea typeface="Calibri" pitchFamily="34" charset="-122"/>
+                <a:cs typeface="Calibri" pitchFamily="34" charset="-120"/>
+              </a:rPr>
+              <a:t>Sarvam STT (₹30/hr)</a:t>
+            </a:r>
+            <a:endParaRPr lang="en-US" sz="900" dirty="0"/>
+          </a:p>
+        </p:txBody>
+      </p:sp>
+      <p:sp>
+        <p:nvSpPr>
+          <p:cNvPr id="19" name="Text 17"/>
+          <p:cNvSpPr txBox="1"/>
+          <p:nvPr/>
+        </p:nvSpPr>
+        <p:spPr>
+          <a:xfrm>
+            <a:off x="3337560" y="3383280"/>
+            <a:ext cx="658368" cy="228600"/>
+          </a:xfrm>
+          <a:prstGeom prst="rect">
+            <a:avLst/>
+          </a:prstGeom>
+          <a:noFill/>
+          <a:ln/>
+        </p:spPr>
+        <p:txBody>
+          <a:bodyPr wrap="square" lIns="0" tIns="0" rIns="0" bIns="0" rtlCol="0" anchor="ctr"/>
+          <a:lstStyle/>
+          <a:p>
+            <a:pPr algn="r" indent="0" marL="0">
+              <a:buNone/>
+            </a:pPr>
+            <a:r>
+              <a:rPr lang="en-US" sz="900" b="1" dirty="0">
                 <a:solidFill>
                   <a:srgbClr val="14213D"/>
                 </a:solidFill>
@@ -3534,73 +3608,32 @@
                 <a:ea typeface="Calibri" pitchFamily="34" charset="-122"/>
                 <a:cs typeface="Calibri" pitchFamily="34" charset="-120"/>
               </a:rPr>
-              <a:t>$10K</a:t>
-            </a:r>
-            <a:endParaRPr lang="en-US" sz="1000" dirty="0"/>
-          </a:p>
-        </p:txBody>
-      </p:sp>
-      <p:sp>
-        <p:nvSpPr>
-          <p:cNvPr id="18" name="Text 16"/>
-          <p:cNvSpPr txBox="1"/>
-          <p:nvPr/>
-        </p:nvSpPr>
-        <p:spPr>
-          <a:xfrm>
-            <a:off x="731520" y="3355848"/>
-            <a:ext cx="1508760" cy="274320"/>
-          </a:xfrm>
-          <a:prstGeom prst="rect">
-            <a:avLst/>
-          </a:prstGeom>
-          <a:noFill/>
-          <a:ln/>
-        </p:spPr>
-        <p:txBody>
-          <a:bodyPr wrap="square" lIns="0" tIns="0" rIns="0" bIns="0" rtlCol="0" anchor="ctr"/>
-          <a:lstStyle/>
-          <a:p>
-            <a:pPr indent="0" marL="0">
-              <a:buNone/>
-            </a:pPr>
-            <a:r>
-              <a:rPr lang="en-US" sz="1050" dirty="0">
-                <a:solidFill>
-                  <a:srgbClr val="1F2937"/>
-                </a:solidFill>
-                <a:latin typeface="Calibri" pitchFamily="34" charset="0"/>
-                <a:ea typeface="Calibri" pitchFamily="34" charset="-122"/>
-                <a:cs typeface="Calibri" pitchFamily="34" charset="-120"/>
-              </a:rPr>
-              <a:t>Part-time PM</a:t>
-            </a:r>
-            <a:endParaRPr lang="en-US" sz="1050" dirty="0"/>
-          </a:p>
-        </p:txBody>
-      </p:sp>
-      <p:sp>
-        <p:nvSpPr>
-          <p:cNvPr id="19" name="Shape 17"/>
+              <a:t>₹1.50</a:t>
+            </a:r>
+            <a:endParaRPr lang="en-US" sz="900" dirty="0"/>
+          </a:p>
+        </p:txBody>
+      </p:sp>
+      <p:sp>
+        <p:nvSpPr>
+          <p:cNvPr id="20" name="Shape 18"/>
           <p:cNvSpPr/>
           <p:nvPr/>
         </p:nvSpPr>
         <p:spPr>
           <a:xfrm>
-            <a:off x="2240280" y="3401568"/>
-            <a:ext cx="164592" cy="182880"/>
-          </a:xfrm>
-          <a:prstGeom prst="roundRect">
-            <a:avLst>
-              <a:gd name="adj" fmla="val 27778"/>
-            </a:avLst>
+            <a:off x="658368" y="3621024"/>
+            <a:ext cx="3383280" cy="228600"/>
+          </a:xfrm>
+          <a:prstGeom prst="rect">
+            <a:avLst/>
           </a:prstGeom>
           <a:solidFill>
-            <a:srgbClr val="2A5C8A"/>
+            <a:srgbClr val="F4F6F9"/>
           </a:solidFill>
           <a:ln w="12700">
             <a:solidFill>
-              <a:srgbClr val="2A5C8A"/>
+              <a:srgbClr val="F4F6F9"/>
             </a:solidFill>
             <a:prstDash val="solid"/>
           </a:ln>
@@ -3608,14 +3641,14 @@
       </p:sp>
       <p:sp>
         <p:nvSpPr>
-          <p:cNvPr id="20" name="Text 18"/>
-          <p:cNvSpPr txBox="1"/>
-          <p:nvPr/>
-        </p:nvSpPr>
-        <p:spPr>
-          <a:xfrm>
-            <a:off x="2450592" y="3355848"/>
-            <a:ext cx="548640" cy="274320"/>
+          <p:cNvPr id="21" name="Text 19"/>
+          <p:cNvSpPr txBox="1"/>
+          <p:nvPr/>
+        </p:nvSpPr>
+        <p:spPr>
+          <a:xfrm>
+            <a:off x="731520" y="3621024"/>
+            <a:ext cx="2651760" cy="228600"/>
           </a:xfrm>
           <a:prstGeom prst="rect">
             <a:avLst/>
@@ -3631,7 +3664,46 @@
               <a:buNone/>
             </a:pPr>
             <a:r>
-              <a:rPr lang="en-US" sz="1000" b="1" dirty="0">
+              <a:rPr lang="en-US" sz="900" dirty="0">
+                <a:solidFill>
+                  <a:srgbClr val="1F2937"/>
+                </a:solidFill>
+                <a:latin typeface="Calibri" pitchFamily="34" charset="0"/>
+                <a:ea typeface="Calibri" pitchFamily="34" charset="-122"/>
+                <a:cs typeface="Calibri" pitchFamily="34" charset="-120"/>
+              </a:rPr>
+              <a:t>ElevenLabs Flash ($0.05/1K chars)</a:t>
+            </a:r>
+            <a:endParaRPr lang="en-US" sz="900" dirty="0"/>
+          </a:p>
+        </p:txBody>
+      </p:sp>
+      <p:sp>
+        <p:nvSpPr>
+          <p:cNvPr id="22" name="Text 20"/>
+          <p:cNvSpPr txBox="1"/>
+          <p:nvPr/>
+        </p:nvSpPr>
+        <p:spPr>
+          <a:xfrm>
+            <a:off x="3337560" y="3621024"/>
+            <a:ext cx="658368" cy="228600"/>
+          </a:xfrm>
+          <a:prstGeom prst="rect">
+            <a:avLst/>
+          </a:prstGeom>
+          <a:noFill/>
+          <a:ln/>
+        </p:spPr>
+        <p:txBody>
+          <a:bodyPr wrap="square" lIns="0" tIns="0" rIns="0" bIns="0" rtlCol="0" anchor="ctr"/>
+          <a:lstStyle/>
+          <a:p>
+            <a:pPr algn="r" indent="0" marL="0">
+              <a:buNone/>
+            </a:pPr>
+            <a:r>
+              <a:rPr lang="en-US" sz="900" b="1" dirty="0">
                 <a:solidFill>
                   <a:srgbClr val="14213D"/>
                 </a:solidFill>
@@ -3639,73 +3711,32 @@
                 <a:ea typeface="Calibri" pitchFamily="34" charset="-122"/>
                 <a:cs typeface="Calibri" pitchFamily="34" charset="-120"/>
               </a:rPr>
-              <a:t>$8K</a:t>
-            </a:r>
-            <a:endParaRPr lang="en-US" sz="1000" dirty="0"/>
-          </a:p>
-        </p:txBody>
-      </p:sp>
-      <p:sp>
-        <p:nvSpPr>
-          <p:cNvPr id="21" name="Text 19"/>
-          <p:cNvSpPr txBox="1"/>
-          <p:nvPr/>
-        </p:nvSpPr>
-        <p:spPr>
-          <a:xfrm>
-            <a:off x="731520" y="3685032"/>
-            <a:ext cx="1508760" cy="274320"/>
-          </a:xfrm>
-          <a:prstGeom prst="rect">
-            <a:avLst/>
-          </a:prstGeom>
-          <a:noFill/>
-          <a:ln/>
-        </p:spPr>
-        <p:txBody>
-          <a:bodyPr wrap="square" lIns="0" tIns="0" rIns="0" bIns="0" rtlCol="0" anchor="ctr"/>
-          <a:lstStyle/>
-          <a:p>
-            <a:pPr indent="0" marL="0">
-              <a:buNone/>
-            </a:pPr>
-            <a:r>
-              <a:rPr lang="en-US" sz="1050" dirty="0">
-                <a:solidFill>
-                  <a:srgbClr val="1F2937"/>
-                </a:solidFill>
-                <a:latin typeface="Calibri" pitchFamily="34" charset="0"/>
-                <a:ea typeface="Calibri" pitchFamily="34" charset="-122"/>
-                <a:cs typeface="Calibri" pitchFamily="34" charset="-120"/>
-              </a:rPr>
-              <a:t>APIs + telephony</a:t>
-            </a:r>
-            <a:endParaRPr lang="en-US" sz="1050" dirty="0"/>
-          </a:p>
-        </p:txBody>
-      </p:sp>
-      <p:sp>
-        <p:nvSpPr>
-          <p:cNvPr id="22" name="Shape 20"/>
+              <a:t>₹6.40</a:t>
+            </a:r>
+            <a:endParaRPr lang="en-US" sz="900" dirty="0"/>
+          </a:p>
+        </p:txBody>
+      </p:sp>
+      <p:sp>
+        <p:nvSpPr>
+          <p:cNvPr id="23" name="Shape 21"/>
           <p:cNvSpPr/>
           <p:nvPr/>
         </p:nvSpPr>
         <p:spPr>
           <a:xfrm>
-            <a:off x="2240280" y="3730752"/>
-            <a:ext cx="144018" cy="182880"/>
-          </a:xfrm>
-          <a:prstGeom prst="roundRect">
-            <a:avLst>
-              <a:gd name="adj" fmla="val 31746"/>
-            </a:avLst>
+            <a:off x="658368" y="3858768"/>
+            <a:ext cx="3383280" cy="228600"/>
+          </a:xfrm>
+          <a:prstGeom prst="rect">
+            <a:avLst/>
           </a:prstGeom>
           <a:solidFill>
-            <a:srgbClr val="2A5C8A"/>
+            <a:srgbClr val="FFFFFF"/>
           </a:solidFill>
           <a:ln w="12700">
             <a:solidFill>
-              <a:srgbClr val="2A5C8A"/>
+              <a:srgbClr val="FFFFFF"/>
             </a:solidFill>
             <a:prstDash val="solid"/>
           </a:ln>
@@ -3713,14 +3744,14 @@
       </p:sp>
       <p:sp>
         <p:nvSpPr>
-          <p:cNvPr id="23" name="Text 21"/>
-          <p:cNvSpPr txBox="1"/>
-          <p:nvPr/>
-        </p:nvSpPr>
-        <p:spPr>
-          <a:xfrm>
-            <a:off x="2430018" y="3685032"/>
-            <a:ext cx="548640" cy="274320"/>
+          <p:cNvPr id="24" name="Text 22"/>
+          <p:cNvSpPr txBox="1"/>
+          <p:nvPr/>
+        </p:nvSpPr>
+        <p:spPr>
+          <a:xfrm>
+            <a:off x="731520" y="3858768"/>
+            <a:ext cx="2651760" cy="228600"/>
           </a:xfrm>
           <a:prstGeom prst="rect">
             <a:avLst/>
@@ -3736,7 +3767,46 @@
               <a:buNone/>
             </a:pPr>
             <a:r>
-              <a:rPr lang="en-US" sz="1000" b="1" dirty="0">
+              <a:rPr lang="en-US" sz="900" dirty="0">
+                <a:solidFill>
+                  <a:srgbClr val="1F2937"/>
+                </a:solidFill>
+                <a:latin typeface="Calibri" pitchFamily="34" charset="0"/>
+                <a:ea typeface="Calibri" pitchFamily="34" charset="-122"/>
+                <a:cs typeface="Calibri" pitchFamily="34" charset="-120"/>
+              </a:rPr>
+              <a:t>Claude checks (Haiku 4.5 / Sonnet 5)</a:t>
+            </a:r>
+            <a:endParaRPr lang="en-US" sz="900" dirty="0"/>
+          </a:p>
+        </p:txBody>
+      </p:sp>
+      <p:sp>
+        <p:nvSpPr>
+          <p:cNvPr id="25" name="Text 23"/>
+          <p:cNvSpPr txBox="1"/>
+          <p:nvPr/>
+        </p:nvSpPr>
+        <p:spPr>
+          <a:xfrm>
+            <a:off x="3337560" y="3858768"/>
+            <a:ext cx="658368" cy="228600"/>
+          </a:xfrm>
+          <a:prstGeom prst="rect">
+            <a:avLst/>
+          </a:prstGeom>
+          <a:noFill/>
+          <a:ln/>
+        </p:spPr>
+        <p:txBody>
+          <a:bodyPr wrap="square" lIns="0" tIns="0" rIns="0" bIns="0" rtlCol="0" anchor="ctr"/>
+          <a:lstStyle/>
+          <a:p>
+            <a:pPr algn="r" indent="0" marL="0">
+              <a:buNone/>
+            </a:pPr>
+            <a:r>
+              <a:rPr lang="en-US" sz="900" b="1" dirty="0">
                 <a:solidFill>
                   <a:srgbClr val="14213D"/>
                 </a:solidFill>
@@ -3744,73 +3814,32 @@
                 <a:ea typeface="Calibri" pitchFamily="34" charset="-122"/>
                 <a:cs typeface="Calibri" pitchFamily="34" charset="-120"/>
               </a:rPr>
-              <a:t>$7K</a:t>
-            </a:r>
-            <a:endParaRPr lang="en-US" sz="1000" dirty="0"/>
-          </a:p>
-        </p:txBody>
-      </p:sp>
-      <p:sp>
-        <p:nvSpPr>
-          <p:cNvPr id="24" name="Text 22"/>
-          <p:cNvSpPr txBox="1"/>
-          <p:nvPr/>
-        </p:nvSpPr>
-        <p:spPr>
-          <a:xfrm>
-            <a:off x="731520" y="4014216"/>
-            <a:ext cx="1508760" cy="274320"/>
-          </a:xfrm>
-          <a:prstGeom prst="rect">
-            <a:avLst/>
-          </a:prstGeom>
-          <a:noFill/>
-          <a:ln/>
-        </p:spPr>
-        <p:txBody>
-          <a:bodyPr wrap="square" lIns="0" tIns="0" rIns="0" bIns="0" rtlCol="0" anchor="ctr"/>
-          <a:lstStyle/>
-          <a:p>
-            <a:pPr indent="0" marL="0">
-              <a:buNone/>
-            </a:pPr>
-            <a:r>
-              <a:rPr lang="en-US" sz="1050" dirty="0">
-                <a:solidFill>
-                  <a:srgbClr val="1F2937"/>
-                </a:solidFill>
-                <a:latin typeface="Calibri" pitchFamily="34" charset="0"/>
-                <a:ea typeface="Calibri" pitchFamily="34" charset="-122"/>
-                <a:cs typeface="Calibri" pitchFamily="34" charset="-120"/>
-              </a:rPr>
-              <a:t>Contingency</a:t>
-            </a:r>
-            <a:endParaRPr lang="en-US" sz="1050" dirty="0"/>
-          </a:p>
-        </p:txBody>
-      </p:sp>
-      <p:sp>
-        <p:nvSpPr>
-          <p:cNvPr id="25" name="Shape 23"/>
+              <a:t>₹0.71</a:t>
+            </a:r>
+            <a:endParaRPr lang="en-US" sz="900" dirty="0"/>
+          </a:p>
+        </p:txBody>
+      </p:sp>
+      <p:sp>
+        <p:nvSpPr>
+          <p:cNvPr id="26" name="Shape 24"/>
           <p:cNvSpPr/>
           <p:nvPr/>
         </p:nvSpPr>
         <p:spPr>
           <a:xfrm>
-            <a:off x="2240280" y="4059936"/>
-            <a:ext cx="102870" cy="182880"/>
-          </a:xfrm>
-          <a:prstGeom prst="roundRect">
-            <a:avLst>
-              <a:gd name="adj" fmla="val 44444"/>
-            </a:avLst>
+            <a:off x="658368" y="4096512"/>
+            <a:ext cx="3383280" cy="228600"/>
+          </a:xfrm>
+          <a:prstGeom prst="rect">
+            <a:avLst/>
           </a:prstGeom>
           <a:solidFill>
-            <a:srgbClr val="2A5C8A"/>
+            <a:srgbClr val="F4F6F9"/>
           </a:solidFill>
           <a:ln w="12700">
             <a:solidFill>
-              <a:srgbClr val="2A5C8A"/>
+              <a:srgbClr val="F4F6F9"/>
             </a:solidFill>
             <a:prstDash val="solid"/>
           </a:ln>
@@ -3818,14 +3847,14 @@
       </p:sp>
       <p:sp>
         <p:nvSpPr>
-          <p:cNvPr id="26" name="Text 24"/>
-          <p:cNvSpPr txBox="1"/>
-          <p:nvPr/>
-        </p:nvSpPr>
-        <p:spPr>
-          <a:xfrm>
-            <a:off x="2388870" y="4014216"/>
-            <a:ext cx="548640" cy="274320"/>
+          <p:cNvPr id="27" name="Text 25"/>
+          <p:cNvSpPr txBox="1"/>
+          <p:nvPr/>
+        </p:nvSpPr>
+        <p:spPr>
+          <a:xfrm>
+            <a:off x="731520" y="4096512"/>
+            <a:ext cx="2651760" cy="228600"/>
           </a:xfrm>
           <a:prstGeom prst="rect">
             <a:avLst/>
@@ -3841,7 +3870,46 @@
               <a:buNone/>
             </a:pPr>
             <a:r>
-              <a:rPr lang="en-US" sz="1000" b="1" dirty="0">
+              <a:rPr lang="en-US" sz="900" dirty="0">
+                <a:solidFill>
+                  <a:srgbClr val="1F2937"/>
+                </a:solidFill>
+                <a:latin typeface="Calibri" pitchFamily="34" charset="0"/>
+                <a:ea typeface="Calibri" pitchFamily="34" charset="-122"/>
+                <a:cs typeface="Calibri" pitchFamily="34" charset="-120"/>
+              </a:rPr>
+              <a:t>Hosting + transcript storage</a:t>
+            </a:r>
+            <a:endParaRPr lang="en-US" sz="900" dirty="0"/>
+          </a:p>
+        </p:txBody>
+      </p:sp>
+      <p:sp>
+        <p:nvSpPr>
+          <p:cNvPr id="28" name="Text 26"/>
+          <p:cNvSpPr txBox="1"/>
+          <p:nvPr/>
+        </p:nvSpPr>
+        <p:spPr>
+          <a:xfrm>
+            <a:off x="3337560" y="4096512"/>
+            <a:ext cx="658368" cy="228600"/>
+          </a:xfrm>
+          <a:prstGeom prst="rect">
+            <a:avLst/>
+          </a:prstGeom>
+          <a:noFill/>
+          <a:ln/>
+        </p:spPr>
+        <p:txBody>
+          <a:bodyPr wrap="square" lIns="0" tIns="0" rIns="0" bIns="0" rtlCol="0" anchor="ctr"/>
+          <a:lstStyle/>
+          <a:p>
+            <a:pPr algn="r" indent="0" marL="0">
+              <a:buNone/>
+            </a:pPr>
+            <a:r>
+              <a:rPr lang="en-US" sz="900" b="1" dirty="0">
                 <a:solidFill>
                   <a:srgbClr val="14213D"/>
                 </a:solidFill>
@@ -3849,22 +3917,125 @@
                 <a:ea typeface="Calibri" pitchFamily="34" charset="-122"/>
                 <a:cs typeface="Calibri" pitchFamily="34" charset="-120"/>
               </a:rPr>
-              <a:t>$5K</a:t>
-            </a:r>
-            <a:endParaRPr lang="en-US" sz="1000" dirty="0"/>
-          </a:p>
-        </p:txBody>
-      </p:sp>
-      <p:sp>
-        <p:nvSpPr>
-          <p:cNvPr id="27" name="Text 25"/>
-          <p:cNvSpPr txBox="1"/>
-          <p:nvPr/>
-        </p:nvSpPr>
-        <p:spPr>
-          <a:xfrm>
-            <a:off x="731520" y="4389120"/>
-            <a:ext cx="3337560" cy="548640"/>
+              <a:t>₹0.43</a:t>
+            </a:r>
+            <a:endParaRPr lang="en-US" sz="900" dirty="0"/>
+          </a:p>
+        </p:txBody>
+      </p:sp>
+      <p:sp>
+        <p:nvSpPr>
+          <p:cNvPr id="29" name="Shape 27"/>
+          <p:cNvSpPr/>
+          <p:nvPr/>
+        </p:nvSpPr>
+        <p:spPr>
+          <a:xfrm>
+            <a:off x="658368" y="4334256"/>
+            <a:ext cx="3383280" cy="228600"/>
+          </a:xfrm>
+          <a:prstGeom prst="rect">
+            <a:avLst/>
+          </a:prstGeom>
+          <a:solidFill>
+            <a:srgbClr val="E1F3EC"/>
+          </a:solidFill>
+          <a:ln w="12700">
+            <a:solidFill>
+              <a:srgbClr val="E1F3EC"/>
+            </a:solidFill>
+            <a:prstDash val="solid"/>
+          </a:ln>
+        </p:spPr>
+      </p:sp>
+      <p:sp>
+        <p:nvSpPr>
+          <p:cNvPr id="30" name="Text 28"/>
+          <p:cNvSpPr txBox="1"/>
+          <p:nvPr/>
+        </p:nvSpPr>
+        <p:spPr>
+          <a:xfrm>
+            <a:off x="731520" y="4334256"/>
+            <a:ext cx="2651760" cy="228600"/>
+          </a:xfrm>
+          <a:prstGeom prst="rect">
+            <a:avLst/>
+          </a:prstGeom>
+          <a:noFill/>
+          <a:ln/>
+        </p:spPr>
+        <p:txBody>
+          <a:bodyPr wrap="square" lIns="0" tIns="0" rIns="0" bIns="0" rtlCol="0" anchor="ctr"/>
+          <a:lstStyle/>
+          <a:p>
+            <a:pPr indent="0" marL="0">
+              <a:buNone/>
+            </a:pPr>
+            <a:r>
+              <a:rPr lang="en-US" sz="900" b="1" dirty="0">
+                <a:solidFill>
+                  <a:srgbClr val="1F8A63"/>
+                </a:solidFill>
+                <a:latin typeface="Calibri" pitchFamily="34" charset="0"/>
+                <a:ea typeface="Calibri" pitchFamily="34" charset="-122"/>
+                <a:cs typeface="Calibri" pitchFamily="34" charset="-120"/>
+              </a:rPr>
+              <a:t>Total ≈ ₹3.5/min vs ₹8 price</a:t>
+            </a:r>
+            <a:endParaRPr lang="en-US" sz="900" dirty="0"/>
+          </a:p>
+        </p:txBody>
+      </p:sp>
+      <p:sp>
+        <p:nvSpPr>
+          <p:cNvPr id="31" name="Text 29"/>
+          <p:cNvSpPr txBox="1"/>
+          <p:nvPr/>
+        </p:nvSpPr>
+        <p:spPr>
+          <a:xfrm>
+            <a:off x="3337560" y="4334256"/>
+            <a:ext cx="658368" cy="228600"/>
+          </a:xfrm>
+          <a:prstGeom prst="rect">
+            <a:avLst/>
+          </a:prstGeom>
+          <a:noFill/>
+          <a:ln/>
+        </p:spPr>
+        <p:txBody>
+          <a:bodyPr wrap="square" lIns="0" tIns="0" rIns="0" bIns="0" rtlCol="0" anchor="ctr"/>
+          <a:lstStyle/>
+          <a:p>
+            <a:pPr algn="r" indent="0" marL="0">
+              <a:buNone/>
+            </a:pPr>
+            <a:r>
+              <a:rPr lang="en-US" sz="900" b="1" dirty="0">
+                <a:solidFill>
+                  <a:srgbClr val="1F8A63"/>
+                </a:solidFill>
+                <a:latin typeface="Calibri" pitchFamily="34" charset="0"/>
+                <a:ea typeface="Calibri" pitchFamily="34" charset="-122"/>
+                <a:cs typeface="Calibri" pitchFamily="34" charset="-120"/>
+              </a:rPr>
+              <a:t>₹10.4</a:t>
+            </a:r>
+            <a:endParaRPr lang="en-US" sz="900" dirty="0"/>
+          </a:p>
+        </p:txBody>
+      </p:sp>
+      <p:sp>
+        <p:nvSpPr>
+          <p:cNvPr id="32" name="Text 30"/>
+          <p:cNvSpPr txBox="1"/>
+          <p:nvPr/>
+        </p:nvSpPr>
+        <p:spPr>
+          <a:xfrm>
+            <a:off x="731520" y="4617720"/>
+            <a:ext cx="3337560" cy="393192"/>
           </a:xfrm>
           <a:prstGeom prst="rect">
             <a:avLst/>
@@ -3880,37 +4051,23 @@
               <a:buNone/>
             </a:pPr>
             <a:r>
-              <a:rPr lang="en-US" sz="1000" b="1" dirty="0">
-                <a:solidFill>
-                  <a:srgbClr val="14213D"/>
-                </a:solidFill>
-                <a:latin typeface="Calibri" pitchFamily="34" charset="0"/>
-                <a:ea typeface="Calibri" pitchFamily="34" charset="-122"/>
-                <a:cs typeface="Calibri" pitchFamily="34" charset="-120"/>
-              </a:rPr>
-              <a:t>Timeline: </a:t>
-            </a:r>
-            <a:pPr indent="0" marL="0">
-              <a:buNone/>
-            </a:pPr>
-            <a:r>
-              <a:rPr lang="en-US" sz="1000" dirty="0">
-                <a:solidFill>
-                  <a:srgbClr val="1F2937"/>
-                </a:solidFill>
-                <a:latin typeface="Calibri" pitchFamily="34" charset="0"/>
-                <a:ea typeface="Calibri" pitchFamily="34" charset="-122"/>
-                <a:cs typeface="Calibri" pitchFamily="34" charset="-120"/>
-              </a:rPr>
-              <a:t>M1 negation data · M2 Claude gate, Dodo, voice path · M3 Freshdesk, audit, pilot</a:t>
-            </a:r>
-            <a:endParaRPr lang="en-US" sz="1000" dirty="0"/>
-          </a:p>
-        </p:txBody>
-      </p:sp>
-      <p:sp>
-        <p:nvSpPr>
-          <p:cNvPr id="28" name="Shape 26"/>
+              <a:rPr lang="en-US" sz="850" i="1" dirty="0">
+                <a:solidFill>
+                  <a:srgbClr val="5B6475"/>
+                </a:solidFill>
+                <a:latin typeface="Calibri" pitchFamily="34" charset="0"/>
+                <a:ea typeface="Calibri" pitchFamily="34" charset="-122"/>
+                <a:cs typeface="Calibri" pitchFamily="34" charset="-120"/>
+              </a:rPr>
+              <a:t>Plug-in only: ₹1.1 cost vs ₹2.55 price per action. Dodo and Freshdesk fees stay on the customer's own plans.</a:t>
+            </a:r>
+            <a:endParaRPr lang="en-US" sz="850" dirty="0"/>
+          </a:p>
+        </p:txBody>
+      </p:sp>
+      <p:sp>
+        <p:nvSpPr>
+          <p:cNvPr id="33" name="Shape 31"/>
           <p:cNvSpPr/>
           <p:nvPr/>
         </p:nvSpPr>
@@ -3944,7 +4101,7 @@
       </p:sp>
       <p:sp>
         <p:nvSpPr>
-          <p:cNvPr id="29" name="Text 27"/>
+          <p:cNvPr id="34" name="Text 32"/>
           <p:cNvSpPr txBox="1"/>
           <p:nvPr/>
         </p:nvSpPr>
@@ -3991,7 +4148,7 @@
       </p:sp>
       <p:sp>
         <p:nvSpPr>
-          <p:cNvPr id="30" name="Text 28"/>
+          <p:cNvPr id="35" name="Text 33"/>
           <p:cNvSpPr txBox="1"/>
           <p:nvPr/>
         </p:nvSpPr>
@@ -4030,7 +4187,7 @@
       </p:sp>
       <p:sp>
         <p:nvSpPr>
-          <p:cNvPr id="31" name="Text 29"/>
+          <p:cNvPr id="36" name="Text 34"/>
           <p:cNvSpPr txBox="1"/>
           <p:nvPr/>
         </p:nvSpPr>
@@ -4069,7 +4226,7 @@
       </p:sp>
       <p:sp>
         <p:nvSpPr>
-          <p:cNvPr id="32" name="Text 30"/>
+          <p:cNvPr id="37" name="Text 35"/>
           <p:cNvSpPr txBox="1"/>
           <p:nvPr/>
         </p:nvSpPr>
@@ -4108,7 +4265,7 @@
       </p:sp>
       <p:sp>
         <p:nvSpPr>
-          <p:cNvPr id="33" name="Shape 31"/>
+          <p:cNvPr id="38" name="Shape 36"/>
           <p:cNvSpPr/>
           <p:nvPr/>
         </p:nvSpPr>
@@ -4133,7 +4290,7 @@
       </p:sp>
       <p:sp>
         <p:nvSpPr>
-          <p:cNvPr id="34" name="Text 32"/>
+          <p:cNvPr id="39" name="Text 37"/>
           <p:cNvSpPr txBox="1"/>
           <p:nvPr/>
         </p:nvSpPr>
@@ -4172,7 +4329,7 @@
       </p:sp>
       <p:sp>
         <p:nvSpPr>
-          <p:cNvPr id="35" name="Text 33"/>
+          <p:cNvPr id="40" name="Text 38"/>
           <p:cNvSpPr txBox="1"/>
           <p:nvPr/>
         </p:nvSpPr>
@@ -4211,7 +4368,7 @@
       </p:sp>
       <p:sp>
         <p:nvSpPr>
-          <p:cNvPr id="36" name="Text 34"/>
+          <p:cNvPr id="41" name="Text 39"/>
           <p:cNvSpPr txBox="1"/>
           <p:nvPr/>
         </p:nvSpPr>
@@ -4250,7 +4407,7 @@
       </p:sp>
       <p:sp>
         <p:nvSpPr>
-          <p:cNvPr id="37" name="Shape 35"/>
+          <p:cNvPr id="42" name="Shape 40"/>
           <p:cNvSpPr/>
           <p:nvPr/>
         </p:nvSpPr>
@@ -4275,7 +4432,7 @@
       </p:sp>
       <p:sp>
         <p:nvSpPr>
-          <p:cNvPr id="38" name="Text 36"/>
+          <p:cNvPr id="43" name="Text 41"/>
           <p:cNvSpPr txBox="1"/>
           <p:nvPr/>
         </p:nvSpPr>
@@ -4314,7 +4471,7 @@
       </p:sp>
       <p:sp>
         <p:nvSpPr>
-          <p:cNvPr id="39" name="Text 37"/>
+          <p:cNvPr id="44" name="Text 42"/>
           <p:cNvSpPr txBox="1"/>
           <p:nvPr/>
         </p:nvSpPr>
@@ -4353,7 +4510,7 @@
       </p:sp>
       <p:sp>
         <p:nvSpPr>
-          <p:cNvPr id="40" name="Text 38"/>
+          <p:cNvPr id="45" name="Text 43"/>
           <p:cNvSpPr txBox="1"/>
           <p:nvPr/>
         </p:nvSpPr>
@@ -4392,7 +4549,7 @@
       </p:sp>
       <p:sp>
         <p:nvSpPr>
-          <p:cNvPr id="41" name="Shape 39"/>
+          <p:cNvPr id="46" name="Shape 44"/>
           <p:cNvSpPr/>
           <p:nvPr/>
         </p:nvSpPr>
@@ -4417,7 +4574,7 @@
       </p:sp>
       <p:sp>
         <p:nvSpPr>
-          <p:cNvPr id="42" name="Text 40"/>
+          <p:cNvPr id="47" name="Text 45"/>
           <p:cNvSpPr txBox="1"/>
           <p:nvPr/>
         </p:nvSpPr>
@@ -4456,7 +4613,7 @@
       </p:sp>
       <p:sp>
         <p:nvSpPr>
-          <p:cNvPr id="43" name="Text 41"/>
+          <p:cNvPr id="48" name="Text 46"/>
           <p:cNvSpPr txBox="1"/>
           <p:nvPr/>
         </p:nvSpPr>
@@ -4495,7 +4652,7 @@
       </p:sp>
       <p:sp>
         <p:nvSpPr>
-          <p:cNvPr id="44" name="Text 42"/>
+          <p:cNvPr id="49" name="Text 47"/>
           <p:cNvSpPr txBox="1"/>
           <p:nvPr/>
         </p:nvSpPr>
@@ -4534,7 +4691,7 @@
       </p:sp>
       <p:sp>
         <p:nvSpPr>
-          <p:cNvPr id="45" name="Shape 43"/>
+          <p:cNvPr id="50" name="Shape 48"/>
           <p:cNvSpPr/>
           <p:nvPr/>
         </p:nvSpPr>
@@ -4559,7 +4716,7 @@
       </p:sp>
       <p:sp>
         <p:nvSpPr>
-          <p:cNvPr id="46" name="Text 44"/>
+          <p:cNvPr id="51" name="Text 49"/>
           <p:cNvSpPr txBox="1"/>
           <p:nvPr/>
         </p:nvSpPr>
@@ -4598,7 +4755,7 @@
       </p:sp>
       <p:sp>
         <p:nvSpPr>
-          <p:cNvPr id="47" name="Text 45"/>
+          <p:cNvPr id="52" name="Text 50"/>
           <p:cNvSpPr txBox="1"/>
           <p:nvPr/>
         </p:nvSpPr>
@@ -4637,7 +4794,7 @@
       </p:sp>
       <p:sp>
         <p:nvSpPr>
-          <p:cNvPr id="48" name="Text 46"/>
+          <p:cNvPr id="53" name="Text 51"/>
           <p:cNvSpPr txBox="1"/>
           <p:nvPr/>
         </p:nvSpPr>
@@ -4676,7 +4833,7 @@
       </p:sp>
       <p:sp>
         <p:nvSpPr>
-          <p:cNvPr id="49" name="Shape 47"/>
+          <p:cNvPr id="54" name="Shape 52"/>
           <p:cNvSpPr/>
           <p:nvPr/>
         </p:nvSpPr>
@@ -4701,7 +4858,7 @@
       </p:sp>
       <p:sp>
         <p:nvSpPr>
-          <p:cNvPr id="50" name="Text 48"/>
+          <p:cNvPr id="55" name="Text 53"/>
           <p:cNvSpPr txBox="1"/>
           <p:nvPr/>
         </p:nvSpPr>
@@ -4740,7 +4897,7 @@
       </p:sp>
       <p:sp>
         <p:nvSpPr>
-          <p:cNvPr id="51" name="Text 49"/>
+          <p:cNvPr id="56" name="Text 54"/>
           <p:cNvSpPr txBox="1"/>
           <p:nvPr/>
         </p:nvSpPr>
@@ -4779,7 +4936,7 @@
       </p:sp>
       <p:sp>
         <p:nvSpPr>
-          <p:cNvPr id="52" name="Text 50"/>
+          <p:cNvPr id="57" name="Text 55"/>
           <p:cNvSpPr txBox="1"/>
           <p:nvPr/>
         </p:nvSpPr>
@@ -4818,7 +4975,7 @@
       </p:sp>
       <p:sp>
         <p:nvSpPr>
-          <p:cNvPr id="53" name="Shape 51"/>
+          <p:cNvPr id="58" name="Shape 56"/>
           <p:cNvSpPr/>
           <p:nvPr/>
         </p:nvSpPr>
@@ -4843,7 +5000,7 @@
       </p:sp>
       <p:sp>
         <p:nvSpPr>
-          <p:cNvPr id="54" name="Text 52"/>
+          <p:cNvPr id="59" name="Text 57"/>
           <p:cNvSpPr txBox="1"/>
           <p:nvPr/>
         </p:nvSpPr>
@@ -4882,7 +5039,7 @@
       </p:sp>
       <p:sp>
         <p:nvSpPr>
-          <p:cNvPr id="55" name="Text 53"/>
+          <p:cNvPr id="60" name="Text 58"/>
           <p:cNvSpPr txBox="1"/>
           <p:nvPr/>
         </p:nvSpPr>
@@ -4921,7 +5078,7 @@
       </p:sp>
       <p:sp>
         <p:nvSpPr>
-          <p:cNvPr id="56" name="Text 54"/>
+          <p:cNvPr id="61" name="Text 59"/>
           <p:cNvSpPr txBox="1"/>
           <p:nvPr/>
         </p:nvSpPr>
@@ -4960,7 +5117,7 @@
       </p:sp>
       <p:sp>
         <p:nvSpPr>
-          <p:cNvPr id="57" name="Shape 55"/>
+          <p:cNvPr id="62" name="Shape 60"/>
           <p:cNvSpPr/>
           <p:nvPr/>
         </p:nvSpPr>
@@ -4985,7 +5142,7 @@
       </p:sp>
       <p:sp>
         <p:nvSpPr>
-          <p:cNvPr id="58" name="Text 56"/>
+          <p:cNvPr id="63" name="Text 61"/>
           <p:cNvSpPr txBox="1"/>
           <p:nvPr/>
         </p:nvSpPr>
@@ -5024,7 +5181,7 @@
       </p:sp>
       <p:sp>
         <p:nvSpPr>
-          <p:cNvPr id="59" name="Text 57"/>
+          <p:cNvPr id="64" name="Text 62"/>
           <p:cNvSpPr txBox="1"/>
           <p:nvPr/>
         </p:nvSpPr>
@@ -5063,7 +5220,7 @@
       </p:sp>
       <p:sp>
         <p:nvSpPr>
-          <p:cNvPr id="60" name="Text 58"/>
+          <p:cNvPr id="65" name="Text 63"/>
           <p:cNvSpPr txBox="1"/>
           <p:nvPr/>
         </p:nvSpPr>
@@ -5102,7 +5259,7 @@
       </p:sp>
       <p:sp>
         <p:nvSpPr>
-          <p:cNvPr id="61" name="Text 59"/>
+          <p:cNvPr id="66" name="Text 64"/>
           <p:cNvSpPr txBox="1"/>
           <p:nvPr/>
         </p:nvSpPr>
@@ -5141,7 +5298,7 @@
       </p:sp>
       <p:sp>
         <p:nvSpPr>
-          <p:cNvPr id="62" name="Shape 60"/>
+          <p:cNvPr id="67" name="Shape 65"/>
           <p:cNvSpPr/>
           <p:nvPr/>
         </p:nvSpPr>
@@ -5175,7 +5332,7 @@
       </p:sp>
       <p:sp>
         <p:nvSpPr>
-          <p:cNvPr id="63" name="Text 61"/>
+          <p:cNvPr id="68" name="Text 66"/>
           <p:cNvSpPr txBox="1"/>
           <p:nvPr/>
         </p:nvSpPr>
@@ -5222,7 +5379,7 @@
       </p:sp>
       <p:sp>
         <p:nvSpPr>
-          <p:cNvPr id="64" name="Text 62"/>
+          <p:cNvPr id="69" name="Text 67"/>
           <p:cNvSpPr txBox="1"/>
           <p:nvPr/>
         </p:nvSpPr>
@@ -5261,7 +5418,7 @@
       </p:sp>
       <p:sp>
         <p:nvSpPr>
-          <p:cNvPr id="65" name="Text 63"/>
+          <p:cNvPr id="70" name="Text 68"/>
           <p:cNvSpPr txBox="1"/>
           <p:nvPr/>
         </p:nvSpPr>
@@ -5317,7 +5474,7 @@
       </p:sp>
       <p:sp>
         <p:nvSpPr>
-          <p:cNvPr id="66" name="Text 64"/>
+          <p:cNvPr id="71" name="Text 69"/>
           <p:cNvSpPr txBox="1"/>
           <p:nvPr/>
         </p:nvSpPr>
@@ -5373,7 +5530,7 @@
       </p:sp>
       <p:sp>
         <p:nvSpPr>
-          <p:cNvPr id="67" name="Text 65"/>
+          <p:cNvPr id="72" name="Text 70"/>
           <p:cNvSpPr txBox="1"/>
           <p:nvPr/>
         </p:nvSpPr>
@@ -5429,7 +5586,7 @@
       </p:sp>
       <p:sp>
         <p:nvSpPr>
-          <p:cNvPr id="68" name="Text 66"/>
+          <p:cNvPr id="73" name="Text 71"/>
           <p:cNvSpPr txBox="1"/>
           <p:nvPr/>
         </p:nvSpPr>
@@ -5485,7 +5642,7 @@
       </p:sp>
       <p:sp>
         <p:nvSpPr>
-          <p:cNvPr id="69" name="Text 67"/>
+          <p:cNvPr id="74" name="Text 72"/>
           <p:cNvSpPr txBox="1"/>
           <p:nvPr/>
         </p:nvSpPr>
@@ -5524,7 +5681,7 @@
       </p:sp>
       <p:sp>
         <p:nvSpPr>
-          <p:cNvPr id="70" name="Text 68"/>
+          <p:cNvPr id="75" name="Text 73"/>
           <p:cNvSpPr txBox="1"/>
           <p:nvPr/>
         </p:nvSpPr>
@@ -5609,7 +5766,7 @@
       </p:sp>
       <p:sp>
         <p:nvSpPr>
-          <p:cNvPr id="71" name="Shape 69"/>
+          <p:cNvPr id="76" name="Shape 74"/>
           <p:cNvSpPr/>
           <p:nvPr/>
         </p:nvSpPr>
@@ -5643,7 +5800,7 @@
       </p:sp>
       <p:sp>
         <p:nvSpPr>
-          <p:cNvPr id="72" name="Text 70"/>
+          <p:cNvPr id="77" name="Text 75"/>
           <p:cNvSpPr txBox="1"/>
           <p:nvPr/>
         </p:nvSpPr>
@@ -5682,7 +5839,7 @@
       </p:sp>
       <p:sp>
         <p:nvSpPr>
-          <p:cNvPr id="73" name="Text 71"/>
+          <p:cNvPr id="78" name="Text 76"/>
           <p:cNvSpPr txBox="1"/>
           <p:nvPr/>
         </p:nvSpPr>
@@ -5713,7 +5870,7 @@
                 <a:ea typeface="Calibri" pitchFamily="34" charset="-122"/>
                 <a:cs typeface="Calibri" pitchFamily="34" charset="-120"/>
               </a:rPr>
-              <a:t>illustrative · built on the deck's pricing assumptions · validated in the pilot</a:t>
+              <a:t>illustrative · full assumptions in speaker notes · validated in the pilot</a:t>
             </a:r>
             <a:endParaRPr lang="en-US" sz="900" dirty="0"/>
           </a:p>
@@ -5721,7 +5878,7 @@
       </p:sp>
       <p:sp>
         <p:nvSpPr>
-          <p:cNvPr id="74" name="Text 72"/>
+          <p:cNvPr id="79" name="Text 77"/>
           <p:cNvSpPr txBox="1"/>
           <p:nvPr/>
         </p:nvSpPr>
@@ -5752,7 +5909,7 @@
                 <a:ea typeface="Cambria" pitchFamily="34" charset="-122"/>
                 <a:cs typeface="Cambria" pitchFamily="34" charset="-120"/>
               </a:rPr>
-              <a:t>~2.3×</a:t>
+              <a:t>~3.8×</a:t>
             </a:r>
             <a:endParaRPr lang="en-US" sz="2200" dirty="0"/>
           </a:p>
@@ -5760,7 +5917,7 @@
       </p:sp>
       <p:sp>
         <p:nvSpPr>
-          <p:cNvPr id="75" name="Text 73"/>
+          <p:cNvPr id="80" name="Text 78"/>
           <p:cNvSpPr txBox="1"/>
           <p:nvPr/>
         </p:nvSpPr>
@@ -5808,7 +5965,7 @@
                 <a:ea typeface="Calibri" pitchFamily="34" charset="-122"/>
                 <a:cs typeface="Calibri" pitchFamily="34" charset="-120"/>
               </a:rPr>
-              <a:t>₹20K saved vs ₹8.5K fee per month</a:t>
+              <a:t>₹1.9L saved vs ₹51K fee / month</a:t>
             </a:r>
             <a:endParaRPr lang="en-US" sz="950" dirty="0"/>
           </a:p>
@@ -5816,7 +5973,7 @@
       </p:sp>
       <p:sp>
         <p:nvSpPr>
-          <p:cNvPr id="76" name="Text 74"/>
+          <p:cNvPr id="81" name="Text 79"/>
           <p:cNvSpPr txBox="1"/>
           <p:nvPr/>
         </p:nvSpPr>
@@ -5847,7 +6004,7 @@
                 <a:ea typeface="Cambria" pitchFamily="34" charset="-122"/>
                 <a:cs typeface="Cambria" pitchFamily="34" charset="-120"/>
               </a:rPr>
-              <a:t>9</a:t>
+              <a:t>0.26%</a:t>
             </a:r>
             <a:endParaRPr lang="en-US" sz="2200" dirty="0"/>
           </a:p>
@@ -5855,7 +6012,7 @@
       </p:sp>
       <p:sp>
         <p:nvSpPr>
-          <p:cNvPr id="77" name="Text 75"/>
+          <p:cNvPr id="82" name="Text 80"/>
           <p:cNvSpPr txBox="1"/>
           <p:nvPr/>
         </p:nvSpPr>
@@ -5903,7 +6060,7 @@
                 <a:ea typeface="Calibri" pitchFamily="34" charset="-122"/>
                 <a:cs typeface="Calibri" pitchFamily="34" charset="-120"/>
               </a:rPr>
-              <a:t>wrong ₹1,000 refunds prevented per month</a:t>
+              <a:t>of guarded actions going wrong</a:t>
             </a:r>
             <a:endParaRPr lang="en-US" sz="950" dirty="0"/>
           </a:p>
@@ -5911,7 +6068,7 @@
       </p:sp>
       <p:sp>
         <p:nvSpPr>
-          <p:cNvPr id="78" name="Text 76"/>
+          <p:cNvPr id="83" name="Text 81"/>
           <p:cNvSpPr txBox="1"/>
           <p:nvPr/>
         </p:nvSpPr>
@@ -5942,7 +6099,7 @@
                 <a:ea typeface="Cambria" pitchFamily="34" charset="-122"/>
                 <a:cs typeface="Cambria" pitchFamily="34" charset="-120"/>
               </a:rPr>
-              <a:t>~1.3×</a:t>
+              <a:t>$349K</a:t>
             </a:r>
             <a:endParaRPr lang="en-US" sz="2200" dirty="0"/>
           </a:p>
@@ -5950,7 +6107,7 @@
       </p:sp>
       <p:sp>
         <p:nvSpPr>
-          <p:cNvPr id="79" name="Text 77"/>
+          <p:cNvPr id="84" name="Text 82"/>
           <p:cNvSpPr txBox="1"/>
           <p:nvPr/>
         </p:nvSpPr>
@@ -5981,7 +6138,7 @@
                 <a:ea typeface="Calibri" pitchFamily="34" charset="-122"/>
                 <a:cs typeface="Calibri" pitchFamily="34" charset="-120"/>
               </a:rPr>
-              <a:t>Year-1 ROI (Freshworks)</a:t>
+              <a:t>Year-1 revenue</a:t>
             </a:r>
             <a:endParaRPr lang="en-US" sz="950" dirty="0"/>
           </a:p>
@@ -5998,7 +6155,7 @@
                 <a:ea typeface="Calibri" pitchFamily="34" charset="-122"/>
                 <a:cs typeface="Calibri" pitchFamily="34" charset="-120"/>
               </a:rPr>
-              <a:t>~$120K ARR on a ~$90K build</a:t>
+              <a:t>vs $90K build · ~$195K gross profit</a:t>
             </a:r>
             <a:endParaRPr lang="en-US" sz="950" dirty="0"/>
           </a:p>
@@ -6006,7 +6163,7 @@
       </p:sp>
       <p:sp>
         <p:nvSpPr>
-          <p:cNvPr id="80" name="Text 78"/>
+          <p:cNvPr id="85" name="Text 83"/>
           <p:cNvSpPr txBox="1"/>
           <p:nvPr/>
         </p:nvSpPr>
@@ -6037,7 +6194,7 @@
                 <a:ea typeface="Cambria" pitchFamily="34" charset="-122"/>
                 <a:cs typeface="Cambria" pitchFamily="34" charset="-120"/>
               </a:rPr>
-              <a:t>~9 mo</a:t>
+              <a:t>~8 mo</a:t>
             </a:r>
             <a:endParaRPr lang="en-US" sz="2200" dirty="0"/>
           </a:p>
@@ -6045,7 +6202,7 @@
       </p:sp>
       <p:sp>
         <p:nvSpPr>
-          <p:cNvPr id="81" name="Text 79"/>
+          <p:cNvPr id="86" name="Text 84"/>
           <p:cNvSpPr txBox="1"/>
           <p:nvPr/>
         </p:nvSpPr>
@@ -6093,7 +6250,7 @@
                 <a:ea typeface="Calibri" pitchFamily="34" charset="-122"/>
                 <a:cs typeface="Calibri" pitchFamily="34" charset="-120"/>
               </a:rPr>
-              <a:t>at ~$10K MRR</a:t>
+              <a:t>after launch, on gross profit</a:t>
             </a:r>
             <a:endParaRPr lang="en-US" sz="950" dirty="0"/>
           </a:p>
@@ -6101,7 +6258,7 @@
       </p:sp>
       <p:sp>
         <p:nvSpPr>
-          <p:cNvPr id="82" name="Text 80"/>
+          <p:cNvPr id="87" name="Text 85"/>
           <p:cNvSpPr txBox="1"/>
           <p:nvPr/>
         </p:nvSpPr>
@@ -19281,8 +19438,8 @@
         </p:nvSpPr>
         <p:spPr>
           <a:xfrm>
-            <a:off x="731520" y="4407408"/>
-            <a:ext cx="1234440" cy="365760"/>
+            <a:off x="731520" y="4370832"/>
+            <a:ext cx="1188720" cy="310896"/>
           </a:xfrm>
           <a:prstGeom prst="rect">
             <a:avLst/>
@@ -19298,7 +19455,7 @@
               <a:buNone/>
             </a:pPr>
             <a:r>
-              <a:rPr lang="en-US" sz="1350" b="1" dirty="0">
+              <a:rPr lang="en-US" sz="1300" b="1" dirty="0">
                 <a:solidFill>
                   <a:srgbClr val="14213D"/>
                 </a:solidFill>
@@ -19308,7 +19465,7 @@
               </a:rPr>
               <a:t>Free</a:t>
             </a:r>
-            <a:endParaRPr lang="en-US" sz="1350" dirty="0"/>
+            <a:endParaRPr lang="en-US" sz="1300" dirty="0"/>
           </a:p>
         </p:txBody>
       </p:sp>
@@ -19320,8 +19477,8 @@
         </p:nvSpPr>
         <p:spPr>
           <a:xfrm>
-            <a:off x="1965960" y="4407408"/>
-            <a:ext cx="3931920" cy="365760"/>
+            <a:off x="1920240" y="4370832"/>
+            <a:ext cx="3977640" cy="310896"/>
           </a:xfrm>
           <a:prstGeom prst="rect">
             <a:avLst/>
@@ -19337,7 +19494,7 @@
               <a:buNone/>
             </a:pPr>
             <a:r>
-              <a:rPr lang="en-US" sz="1050" dirty="0">
+              <a:rPr lang="en-US" sz="1000" dirty="0">
                 <a:solidFill>
                   <a:srgbClr val="1F2937"/>
                 </a:solidFill>
@@ -19347,7 +19504,7 @@
               </a:rPr>
               <a:t>Monitor mode: flags risky actions, never blocks</a:t>
             </a:r>
-            <a:endParaRPr lang="en-US" sz="1050" dirty="0"/>
+            <a:endParaRPr lang="en-US" sz="1000" dirty="0"/>
           </a:p>
         </p:txBody>
       </p:sp>
@@ -19359,8 +19516,8 @@
         </p:nvSpPr>
         <p:spPr>
           <a:xfrm>
-            <a:off x="731520" y="4809744"/>
-            <a:ext cx="1234440" cy="365760"/>
+            <a:off x="731520" y="4700016"/>
+            <a:ext cx="1188720" cy="310896"/>
           </a:xfrm>
           <a:prstGeom prst="rect">
             <a:avLst/>
@@ -19376,7 +19533,7 @@
               <a:buNone/>
             </a:pPr>
             <a:r>
-              <a:rPr lang="en-US" sz="1350" b="1" dirty="0">
+              <a:rPr lang="en-US" sz="1300" b="1" dirty="0">
                 <a:solidFill>
                   <a:srgbClr val="7A5000"/>
                 </a:solidFill>
@@ -19384,9 +19541,9 @@
                 <a:ea typeface="Cambria" pitchFamily="34" charset="-122"/>
                 <a:cs typeface="Cambria" pitchFamily="34" charset="-120"/>
               </a:rPr>
-              <a:t>$5 / 1,000</a:t>
-            </a:r>
-            <a:endParaRPr lang="en-US" sz="1350" dirty="0"/>
+              <a:t>$0.03</a:t>
+            </a:r>
+            <a:endParaRPr lang="en-US" sz="1300" dirty="0"/>
           </a:p>
         </p:txBody>
       </p:sp>
@@ -19398,8 +19555,8 @@
         </p:nvSpPr>
         <p:spPr>
           <a:xfrm>
-            <a:off x="1965960" y="4809744"/>
-            <a:ext cx="3931920" cy="365760"/>
+            <a:off x="1920240" y="4700016"/>
+            <a:ext cx="3977640" cy="310896"/>
           </a:xfrm>
           <a:prstGeom prst="rect">
             <a:avLst/>
@@ -19415,7 +19572,7 @@
               <a:buNone/>
             </a:pPr>
             <a:r>
-              <a:rPr lang="en-US" sz="1050" dirty="0">
+              <a:rPr lang="en-US" sz="1000" dirty="0">
                 <a:solidFill>
                   <a:srgbClr val="1F2937"/>
                 </a:solidFill>
@@ -19423,9 +19580,9 @@
                 <a:ea typeface="Calibri" pitchFamily="34" charset="-122"/>
                 <a:cs typeface="Calibri" pitchFamily="34" charset="-120"/>
               </a:rPr>
-              <a:t>guarded actions: full gate, DTMF, Freshdesk, audit · 30 days free</a:t>
-            </a:r>
-            <a:endParaRPr lang="en-US" sz="1050" dirty="0"/>
+              <a:t>per guarded action: plug-in on the customer's own agent</a:t>
+            </a:r>
+            <a:endParaRPr lang="en-US" sz="1000" dirty="0"/>
           </a:p>
         </p:txBody>
       </p:sp>
@@ -19437,8 +19594,8 @@
         </p:nvSpPr>
         <p:spPr>
           <a:xfrm>
-            <a:off x="731520" y="5212080"/>
-            <a:ext cx="1234440" cy="365760"/>
+            <a:off x="731520" y="5029200"/>
+            <a:ext cx="1188720" cy="310896"/>
           </a:xfrm>
           <a:prstGeom prst="rect">
             <a:avLst/>
@@ -19454,30 +19611,108 @@
               <a:buNone/>
             </a:pPr>
             <a:r>
-              <a:rPr lang="en-US" sz="1350" b="1" dirty="0">
-                <a:solidFill>
-                  <a:srgbClr val="14213D"/>
+              <a:rPr lang="en-US" sz="1300" b="1" dirty="0">
+                <a:solidFill>
+                  <a:srgbClr val="7A5000"/>
                 </a:solidFill>
                 <a:latin typeface="Cambria" pitchFamily="34" charset="0"/>
                 <a:ea typeface="Cambria" pitchFamily="34" charset="-122"/>
                 <a:cs typeface="Cambria" pitchFamily="34" charset="-120"/>
               </a:rPr>
+              <a:t>₹8 / min</a:t>
+            </a:r>
+            <a:endParaRPr lang="en-US" sz="1300" dirty="0"/>
+          </a:p>
+        </p:txBody>
+      </p:sp>
+      <p:sp>
+        <p:nvSpPr>
+          <p:cNvPr id="27" name="Text 25"/>
+          <p:cNvSpPr txBox="1"/>
+          <p:nvPr/>
+        </p:nvSpPr>
+        <p:spPr>
+          <a:xfrm>
+            <a:off x="1920240" y="5029200"/>
+            <a:ext cx="3977640" cy="310896"/>
+          </a:xfrm>
+          <a:prstGeom prst="rect">
+            <a:avLst/>
+          </a:prstGeom>
+          <a:noFill/>
+          <a:ln/>
+        </p:spPr>
+        <p:txBody>
+          <a:bodyPr wrap="square" lIns="0" tIns="0" rIns="0" bIns="0" rtlCol="0" anchor="ctr"/>
+          <a:lstStyle/>
+          <a:p>
+            <a:pPr indent="0" marL="0">
+              <a:buNone/>
+            </a:pPr>
+            <a:r>
+              <a:rPr lang="en-US" sz="1000" dirty="0">
+                <a:solidFill>
+                  <a:srgbClr val="1F2937"/>
+                </a:solidFill>
+                <a:latin typeface="Calibri" pitchFamily="34" charset="0"/>
+                <a:ea typeface="Calibri" pitchFamily="34" charset="-122"/>
+                <a:cs typeface="Calibri" pitchFamily="34" charset="-120"/>
+              </a:rPr>
+              <a:t>full voice agent: VoBiz + Sarvam + Claude + ElevenLabs + Freshdesk</a:t>
+            </a:r>
+            <a:endParaRPr lang="en-US" sz="1000" dirty="0"/>
+          </a:p>
+        </p:txBody>
+      </p:sp>
+      <p:sp>
+        <p:nvSpPr>
+          <p:cNvPr id="28" name="Text 26"/>
+          <p:cNvSpPr txBox="1"/>
+          <p:nvPr/>
+        </p:nvSpPr>
+        <p:spPr>
+          <a:xfrm>
+            <a:off x="731520" y="5358384"/>
+            <a:ext cx="1188720" cy="310896"/>
+          </a:xfrm>
+          <a:prstGeom prst="rect">
+            <a:avLst/>
+          </a:prstGeom>
+          <a:noFill/>
+          <a:ln/>
+        </p:spPr>
+        <p:txBody>
+          <a:bodyPr wrap="square" lIns="0" tIns="0" rIns="0" bIns="0" rtlCol="0" anchor="ctr"/>
+          <a:lstStyle/>
+          <a:p>
+            <a:pPr indent="0" marL="0">
+              <a:buNone/>
+            </a:pPr>
+            <a:r>
+              <a:rPr lang="en-US" sz="1300" b="1" dirty="0">
+                <a:solidFill>
+                  <a:srgbClr val="14213D"/>
+                </a:solidFill>
+                <a:latin typeface="Cambria" pitchFamily="34" charset="0"/>
+                <a:ea typeface="Cambria" pitchFamily="34" charset="-122"/>
+                <a:cs typeface="Cambria" pitchFamily="34" charset="-120"/>
+              </a:rPr>
               <a:t>Custom</a:t>
             </a:r>
-            <a:endParaRPr lang="en-US" sz="1350" dirty="0"/>
-          </a:p>
-        </p:txBody>
-      </p:sp>
-      <p:sp>
-        <p:nvSpPr>
-          <p:cNvPr id="27" name="Text 25"/>
-          <p:cNvSpPr txBox="1"/>
-          <p:nvPr/>
-        </p:nvSpPr>
-        <p:spPr>
-          <a:xfrm>
-            <a:off x="1965960" y="5212080"/>
-            <a:ext cx="3931920" cy="365760"/>
+            <a:endParaRPr lang="en-US" sz="1300" dirty="0"/>
+          </a:p>
+        </p:txBody>
+      </p:sp>
+      <p:sp>
+        <p:nvSpPr>
+          <p:cNvPr id="29" name="Text 27"/>
+          <p:cNvSpPr txBox="1"/>
+          <p:nvPr/>
+        </p:nvSpPr>
+        <p:spPr>
+          <a:xfrm>
+            <a:off x="1920240" y="5358384"/>
+            <a:ext cx="3977640" cy="310896"/>
           </a:xfrm>
           <a:prstGeom prst="rect">
             <a:avLst/>
@@ -19493,7 +19728,7 @@
               <a:buNone/>
             </a:pPr>
             <a:r>
-              <a:rPr lang="en-US" sz="1050" dirty="0">
+              <a:rPr lang="en-US" sz="1000" dirty="0">
                 <a:solidFill>
                   <a:srgbClr val="1F2937"/>
                 </a:solidFill>
@@ -19503,20 +19738,20 @@
               </a:rPr>
               <a:t>Enterprise: SOP rule packs, India data residency, SLA</a:t>
             </a:r>
-            <a:endParaRPr lang="en-US" sz="1050" dirty="0"/>
-          </a:p>
-        </p:txBody>
-      </p:sp>
-      <p:sp>
-        <p:nvSpPr>
-          <p:cNvPr id="28" name="Text 26"/>
-          <p:cNvSpPr txBox="1"/>
-          <p:nvPr/>
-        </p:nvSpPr>
-        <p:spPr>
-          <a:xfrm>
-            <a:off x="731520" y="5623560"/>
-            <a:ext cx="5120640" cy="457200"/>
+            <a:endParaRPr lang="en-US" sz="1000" dirty="0"/>
+          </a:p>
+        </p:txBody>
+      </p:sp>
+      <p:sp>
+        <p:nvSpPr>
+          <p:cNvPr id="30" name="Text 28"/>
+          <p:cNvSpPr txBox="1"/>
+          <p:nvPr/>
+        </p:nvSpPr>
+        <p:spPr>
+          <a:xfrm>
+            <a:off x="731520" y="5687568"/>
+            <a:ext cx="5120640" cy="411480"/>
           </a:xfrm>
           <a:prstGeom prst="rect">
             <a:avLst/>
@@ -19532,7 +19767,7 @@
               <a:buNone/>
             </a:pPr>
             <a:r>
-              <a:rPr lang="en-US" sz="1000" i="1" dirty="0">
+              <a:rPr lang="en-US" sz="950" i="1" dirty="0">
                 <a:solidFill>
                   <a:srgbClr val="5B6475"/>
                 </a:solidFill>
@@ -19540,15 +19775,15 @@
                 <a:ea typeface="Calibri" pitchFamily="34" charset="-122"/>
                 <a:cs typeface="Calibri" pitchFamily="34" charset="-120"/>
               </a:rPr>
-              <a:t>Only sensitive actions are metered: one prevented ₹1,000 wrong refund pays for 2,000+ guarded actions (~2.3× customer ROI, slide 10).</a:t>
-            </a:r>
-            <a:endParaRPr lang="en-US" sz="1000" dirty="0"/>
-          </a:p>
-        </p:txBody>
-      </p:sp>
-      <p:sp>
-        <p:nvSpPr>
-          <p:cNvPr id="29" name="Shape 27"/>
+              <a:t>Priced above run cost (~55% gross margin, slide 10). One prevented ₹1,000 wrong refund pays for ~390 guarded actions.</a:t>
+            </a:r>
+            <a:endParaRPr lang="en-US" sz="950" dirty="0"/>
+          </a:p>
+        </p:txBody>
+      </p:sp>
+      <p:sp>
+        <p:nvSpPr>
+          <p:cNvPr id="31" name="Shape 29"/>
           <p:cNvSpPr/>
           <p:nvPr/>
         </p:nvSpPr>
@@ -19582,7 +19817,7 @@
       </p:sp>
       <p:sp>
         <p:nvSpPr>
-          <p:cNvPr id="30" name="Text 28"/>
+          <p:cNvPr id="32" name="Text 30"/>
           <p:cNvSpPr txBox="1"/>
           <p:nvPr/>
         </p:nvSpPr>
@@ -19629,7 +19864,7 @@
       </p:sp>
       <p:sp>
         <p:nvSpPr>
-          <p:cNvPr id="31" name="Text 29"/>
+          <p:cNvPr id="33" name="Text 31"/>
           <p:cNvSpPr txBox="1"/>
           <p:nvPr/>
         </p:nvSpPr>
@@ -19668,7 +19903,7 @@
       </p:sp>
       <p:sp>
         <p:nvSpPr>
-          <p:cNvPr id="32" name="Shape 30"/>
+          <p:cNvPr id="34" name="Shape 32"/>
           <p:cNvSpPr/>
           <p:nvPr/>
         </p:nvSpPr>
@@ -19693,7 +19928,7 @@
       </p:sp>
       <p:sp>
         <p:nvSpPr>
-          <p:cNvPr id="33" name="Text 31"/>
+          <p:cNvPr id="35" name="Text 33"/>
           <p:cNvSpPr txBox="1"/>
           <p:nvPr/>
         </p:nvSpPr>
@@ -19732,7 +19967,7 @@
       </p:sp>
       <p:sp>
         <p:nvSpPr>
-          <p:cNvPr id="34" name="Text 32"/>
+          <p:cNvPr id="36" name="Text 34"/>
           <p:cNvSpPr txBox="1"/>
           <p:nvPr/>
         </p:nvSpPr>
@@ -19771,7 +20006,7 @@
       </p:sp>
       <p:sp>
         <p:nvSpPr>
-          <p:cNvPr id="35" name="Shape 33"/>
+          <p:cNvPr id="37" name="Shape 35"/>
           <p:cNvSpPr/>
           <p:nvPr/>
         </p:nvSpPr>
@@ -19796,7 +20031,7 @@
       </p:sp>
       <p:sp>
         <p:nvSpPr>
-          <p:cNvPr id="36" name="Text 34"/>
+          <p:cNvPr id="38" name="Text 36"/>
           <p:cNvSpPr txBox="1"/>
           <p:nvPr/>
         </p:nvSpPr>
@@ -19835,7 +20070,7 @@
       </p:sp>
       <p:sp>
         <p:nvSpPr>
-          <p:cNvPr id="37" name="Text 35"/>
+          <p:cNvPr id="39" name="Text 37"/>
           <p:cNvSpPr txBox="1"/>
           <p:nvPr/>
         </p:nvSpPr>
@@ -19874,7 +20109,7 @@
       </p:sp>
       <p:sp>
         <p:nvSpPr>
-          <p:cNvPr id="38" name="Shape 36"/>
+          <p:cNvPr id="40" name="Shape 38"/>
           <p:cNvSpPr/>
           <p:nvPr/>
         </p:nvSpPr>
@@ -19899,7 +20134,7 @@
       </p:sp>
       <p:sp>
         <p:nvSpPr>
-          <p:cNvPr id="39" name="Text 37"/>
+          <p:cNvPr id="41" name="Text 39"/>
           <p:cNvSpPr txBox="1"/>
           <p:nvPr/>
         </p:nvSpPr>
@@ -19938,7 +20173,7 @@
       </p:sp>
       <p:sp>
         <p:nvSpPr>
-          <p:cNvPr id="40" name="Text 38"/>
+          <p:cNvPr id="42" name="Text 40"/>
           <p:cNvSpPr txBox="1"/>
           <p:nvPr/>
         </p:nvSpPr>
@@ -19977,7 +20212,7 @@
       </p:sp>
       <p:sp>
         <p:nvSpPr>
-          <p:cNvPr id="41" name="Shape 39"/>
+          <p:cNvPr id="43" name="Shape 41"/>
           <p:cNvSpPr/>
           <p:nvPr/>
         </p:nvSpPr>
@@ -20002,7 +20237,7 @@
       </p:sp>
       <p:sp>
         <p:nvSpPr>
-          <p:cNvPr id="42" name="Text 40"/>
+          <p:cNvPr id="44" name="Text 42"/>
           <p:cNvSpPr txBox="1"/>
           <p:nvPr/>
         </p:nvSpPr>
@@ -20041,7 +20276,7 @@
       </p:sp>
       <p:sp>
         <p:nvSpPr>
-          <p:cNvPr id="43" name="Text 41"/>
+          <p:cNvPr id="45" name="Text 43"/>
           <p:cNvSpPr txBox="1"/>
           <p:nvPr/>
         </p:nvSpPr>
@@ -20080,7 +20315,7 @@
       </p:sp>
       <p:sp>
         <p:nvSpPr>
-          <p:cNvPr id="44" name="Shape 42"/>
+          <p:cNvPr id="46" name="Shape 44"/>
           <p:cNvSpPr/>
           <p:nvPr/>
         </p:nvSpPr>
@@ -20105,7 +20340,7 @@
       </p:sp>
       <p:sp>
         <p:nvSpPr>
-          <p:cNvPr id="45" name="Text 43"/>
+          <p:cNvPr id="47" name="Text 45"/>
           <p:cNvSpPr txBox="1"/>
           <p:nvPr/>
         </p:nvSpPr>
@@ -20144,7 +20379,7 @@
       </p:sp>
       <p:sp>
         <p:nvSpPr>
-          <p:cNvPr id="46" name="Text 44"/>
+          <p:cNvPr id="48" name="Text 46"/>
           <p:cNvSpPr txBox="1"/>
           <p:nvPr/>
         </p:nvSpPr>
@@ -20183,7 +20418,7 @@
       </p:sp>
       <p:sp>
         <p:nvSpPr>
-          <p:cNvPr id="47" name="Text 45"/>
+          <p:cNvPr id="49" name="Text 47"/>
           <p:cNvSpPr txBox="1"/>
           <p:nvPr/>
         </p:nvSpPr>

</xml_diff>

<commit_message>
docs: show Year-1 revenue split in the ROI strip
Co-Authored-By: Claude Opus 5.5 <noreply@anthropic.com>
Claude-Session: https://claude.ai/code/session_012DT45KpxUQbVV43mbMd9KB
</commit_message>
<xml_diff>
--- a/docs/presentation/CodemixSkill-Final-10-Slides.pptx
+++ b/docs/presentation/CodemixSkill-Final-10-Slides.pptx
@@ -5772,12 +5772,12 @@
         </p:nvSpPr>
         <p:spPr>
           <a:xfrm>
-            <a:off x="548640" y="5166360"/>
-            <a:ext cx="11109960" cy="1051560"/>
+            <a:off x="548640" y="5138928"/>
+            <a:ext cx="11109960" cy="1243584"/>
           </a:xfrm>
           <a:prstGeom prst="roundRect">
             <a:avLst>
-              <a:gd name="adj" fmla="val 8696"/>
+              <a:gd name="adj" fmla="val 7353"/>
             </a:avLst>
           </a:prstGeom>
           <a:solidFill>
@@ -5806,7 +5806,7 @@
         </p:nvSpPr>
         <p:spPr>
           <a:xfrm>
-            <a:off x="777240" y="5230368"/>
+            <a:off x="777240" y="5148072"/>
             <a:ext cx="2743200" cy="237744"/>
           </a:xfrm>
           <a:prstGeom prst="rect">
@@ -5845,7 +5845,7 @@
         </p:nvSpPr>
         <p:spPr>
           <a:xfrm>
-            <a:off x="3291840" y="5230368"/>
+            <a:off x="3291840" y="5148072"/>
             <a:ext cx="8138160" cy="237744"/>
           </a:xfrm>
           <a:prstGeom prst="rect">
@@ -5884,8 +5884,8 @@
         </p:nvSpPr>
         <p:spPr>
           <a:xfrm>
-            <a:off x="777240" y="5486400"/>
-            <a:ext cx="1234440" cy="658368"/>
+            <a:off x="777240" y="5376672"/>
+            <a:ext cx="1234440" cy="566928"/>
           </a:xfrm>
           <a:prstGeom prst="rect">
             <a:avLst/>
@@ -5923,8 +5923,8 @@
         </p:nvSpPr>
         <p:spPr>
           <a:xfrm>
-            <a:off x="2039112" y="5486400"/>
-            <a:ext cx="1417320" cy="658368"/>
+            <a:off x="2039112" y="5376672"/>
+            <a:ext cx="1417320" cy="566928"/>
           </a:xfrm>
           <a:prstGeom prst="rect">
             <a:avLst/>
@@ -5979,8 +5979,8 @@
         </p:nvSpPr>
         <p:spPr>
           <a:xfrm>
-            <a:off x="3520440" y="5486400"/>
-            <a:ext cx="1234440" cy="658368"/>
+            <a:off x="3520440" y="5376672"/>
+            <a:ext cx="1234440" cy="566928"/>
           </a:xfrm>
           <a:prstGeom prst="rect">
             <a:avLst/>
@@ -6018,8 +6018,8 @@
         </p:nvSpPr>
         <p:spPr>
           <a:xfrm>
-            <a:off x="4782312" y="5486400"/>
-            <a:ext cx="1417320" cy="658368"/>
+            <a:off x="4782312" y="5376672"/>
+            <a:ext cx="1417320" cy="566928"/>
           </a:xfrm>
           <a:prstGeom prst="rect">
             <a:avLst/>
@@ -6074,8 +6074,8 @@
         </p:nvSpPr>
         <p:spPr>
           <a:xfrm>
-            <a:off x="6263640" y="5486400"/>
-            <a:ext cx="1234440" cy="658368"/>
+            <a:off x="6263640" y="5376672"/>
+            <a:ext cx="1234440" cy="566928"/>
           </a:xfrm>
           <a:prstGeom prst="rect">
             <a:avLst/>
@@ -6113,8 +6113,8 @@
         </p:nvSpPr>
         <p:spPr>
           <a:xfrm>
-            <a:off x="7525512" y="5486400"/>
-            <a:ext cx="1417320" cy="658368"/>
+            <a:off x="7525512" y="5376672"/>
+            <a:ext cx="1417320" cy="566928"/>
           </a:xfrm>
           <a:prstGeom prst="rect">
             <a:avLst/>
@@ -6169,8 +6169,8 @@
         </p:nvSpPr>
         <p:spPr>
           <a:xfrm>
-            <a:off x="9006840" y="5486400"/>
-            <a:ext cx="1234440" cy="658368"/>
+            <a:off x="9006840" y="5376672"/>
+            <a:ext cx="1234440" cy="566928"/>
           </a:xfrm>
           <a:prstGeom prst="rect">
             <a:avLst/>
@@ -6208,8 +6208,8 @@
         </p:nvSpPr>
         <p:spPr>
           <a:xfrm>
-            <a:off x="10268712" y="5486400"/>
-            <a:ext cx="1417320" cy="658368"/>
+            <a:off x="10268712" y="5376672"/>
+            <a:ext cx="1417320" cy="566928"/>
           </a:xfrm>
           <a:prstGeom prst="rect">
             <a:avLst/>
@@ -6258,7 +6258,125 @@
       </p:sp>
       <p:sp>
         <p:nvSpPr>
-          <p:cNvPr id="87" name="Text 85"/>
+          <p:cNvPr id="87" name="Shape 85"/>
+          <p:cNvSpPr/>
+          <p:nvPr/>
+        </p:nvSpPr>
+        <p:spPr>
+          <a:xfrm>
+            <a:off x="777240" y="5989320"/>
+            <a:ext cx="10652760" cy="0"/>
+          </a:xfrm>
+          <a:prstGeom prst="line">
+            <a:avLst/>
+          </a:prstGeom>
+          <a:noFill/>
+          <a:ln w="12700">
+            <a:solidFill>
+              <a:srgbClr val="1F3057"/>
+            </a:solidFill>
+            <a:prstDash val="solid"/>
+          </a:ln>
+        </p:spPr>
+      </p:sp>
+      <p:sp>
+        <p:nvSpPr>
+          <p:cNvPr id="88" name="Text 86"/>
+          <p:cNvSpPr txBox="1"/>
+          <p:nvPr/>
+        </p:nvSpPr>
+        <p:spPr>
+          <a:xfrm>
+            <a:off x="777240" y="6035040"/>
+            <a:ext cx="10744200" cy="301752"/>
+          </a:xfrm>
+          <a:prstGeom prst="rect">
+            <a:avLst/>
+          </a:prstGeom>
+          <a:noFill/>
+          <a:ln/>
+        </p:spPr>
+        <p:txBody>
+          <a:bodyPr wrap="square" lIns="0" tIns="0" rIns="0" bIns="0" rtlCol="0" anchor="ctr"/>
+          <a:lstStyle/>
+          <a:p>
+            <a:pPr indent="0" marL="0">
+              <a:buNone/>
+            </a:pPr>
+            <a:r>
+              <a:rPr lang="en-US" sz="950" b="1" dirty="0">
+                <a:solidFill>
+                  <a:srgbClr val="F4A300"/>
+                </a:solidFill>
+                <a:latin typeface="Calibri" pitchFamily="34" charset="0"/>
+                <a:ea typeface="Calibri" pitchFamily="34" charset="-122"/>
+                <a:cs typeface="Calibri" pitchFamily="34" charset="-120"/>
+              </a:rPr>
+              <a:t>REVENUE SPLIT  </a:t>
+            </a:r>
+            <a:pPr indent="0" marL="0">
+              <a:buNone/>
+            </a:pPr>
+            <a:r>
+              <a:rPr lang="en-US" sz="1050" b="1" dirty="0">
+                <a:solidFill>
+                  <a:srgbClr val="FFFFFF"/>
+                </a:solidFill>
+                <a:latin typeface="Calibri" pitchFamily="34" charset="0"/>
+                <a:ea typeface="Calibri" pitchFamily="34" charset="-122"/>
+                <a:cs typeface="Calibri" pitchFamily="34" charset="-120"/>
+              </a:rPr>
+              <a:t>Plug-in: </a:t>
+            </a:r>
+            <a:pPr indent="0" marL="0">
+              <a:buNone/>
+            </a:pPr>
+            <a:r>
+              <a:rPr lang="en-US" sz="1050" dirty="0">
+                <a:solidFill>
+                  <a:srgbClr val="CADCFC"/>
+                </a:solidFill>
+                <a:latin typeface="Calibri" pitchFamily="34" charset="0"/>
+                <a:ea typeface="Calibri" pitchFamily="34" charset="-122"/>
+                <a:cs typeface="Calibri" pitchFamily="34" charset="-120"/>
+              </a:rPr>
+              <a:t>25 avg customers × $600/mo = $180K → $99K profit</a:t>
+            </a:r>
+            <a:pPr indent="0" marL="0">
+              <a:buNone/>
+            </a:pPr>
+            <a:r>
+              <a:rPr lang="en-US" sz="1050" b="1" dirty="0">
+                <a:solidFill>
+                  <a:srgbClr val="FFFFFF"/>
+                </a:solidFill>
+                <a:latin typeface="Calibri" pitchFamily="34" charset="0"/>
+                <a:ea typeface="Calibri" pitchFamily="34" charset="-122"/>
+                <a:cs typeface="Calibri" pitchFamily="34" charset="-120"/>
+              </a:rPr>
+              <a:t>   ·   Voice agent: </a:t>
+            </a:r>
+            <a:pPr indent="0" marL="0">
+              <a:buNone/>
+            </a:pPr>
+            <a:r>
+              <a:rPr lang="en-US" sz="1050" dirty="0">
+                <a:solidFill>
+                  <a:srgbClr val="CADCFC"/>
+                </a:solidFill>
+                <a:latin typeface="Calibri" pitchFamily="34" charset="0"/>
+                <a:ea typeface="Calibri" pitchFamily="34" charset="-122"/>
+                <a:cs typeface="Calibri" pitchFamily="34" charset="-120"/>
+              </a:rPr>
+              <a:t>5 avg brands × $2,824/mo = $169K → $96K profit</a:t>
+            </a:r>
+            <a:endParaRPr lang="en-US" sz="1050" dirty="0"/>
+          </a:p>
+        </p:txBody>
+      </p:sp>
+      <p:sp>
+        <p:nvSpPr>
+          <p:cNvPr id="89" name="Text 87"/>
           <p:cNvSpPr txBox="1"/>
           <p:nvPr/>
         </p:nvSpPr>

</xml_diff>

<commit_message>
docs: limit benchmark and deck to Hindi, Tamil, English and Kannada
Drops the Telugu and Bengali test sentences and re-runs the negation
benchmark: Round-1 engine alone 10/21 (47.6%) wrong actions, with the
v0 gate 0/21, 0/18 genuine requests blocked. Deck figures updated.

Co-Authored-By: Claude Opus 5.5 <noreply@anthropic.com>
Claude-Session: https://claude.ai/code/session_012DT45KpxUQbVV43mbMd9KB
</commit_message>
<xml_diff>
--- a/docs/presentation/CodemixSkill-Final-10-Slides.pptx
+++ b/docs/presentation/CodemixSkill-Final-10-Slides.pptx
@@ -222,7 +222,7 @@
                 <c:formatCode>General</c:formatCode>
                 <c:ptCount val="1"/>
                 <c:pt idx="0">
-                  <c:v>47.8</c:v>
+                  <c:v>47.6</c:v>
                 </c:pt>
               </c:numCache>
             </c:numRef>
@@ -1548,7 +1548,7 @@
           <a:p>
             <a:r>
               <a:rPr lang="en-US" dirty="0"/>
-              <a:t>Reproduce: node decision-policy/negation-benchmark.mjs. The same run shows the Round-1 keyword engine recognised only 7 of 20 genuine requests, which is why the MVP uses Claude for intent.</a:t>
+              <a:t>Reproduce: node decision-policy/negation-benchmark.mjs. The same run shows the Round-1 keyword engine recognised only 6 of 18 genuine requests, which is why the MVP uses Claude for intent.</a:t>
             </a:r>
             <a:endParaRPr lang="en-US" dirty="0"/>
           </a:p>
@@ -5212,7 +5212,7 @@
                 <a:ea typeface="Calibri" pitchFamily="34" charset="-122"/>
                 <a:cs typeface="Calibri" pitchFamily="34" charset="-120"/>
               </a:rPr>
-              <a:t>* Round-1 engine, no gate, 23-sentence test set   † npm test average</a:t>
+              <a:t>* Round-1 engine, no gate, 21-sentence test set   † npm test average</a:t>
             </a:r>
             <a:endParaRPr lang="en-US" sz="850" dirty="0"/>
           </a:p>
@@ -7293,7 +7293,7 @@
                 <a:ea typeface="Calibri" pitchFamily="34" charset="-122"/>
                 <a:cs typeface="Calibri" pitchFamily="34" charset="-120"/>
               </a:rPr>
-              <a:t>Measured: 11 of 23 team-written test sentences (Hindi, Tamil, English, Telugu, Kannada, Bengali)</a:t>
+              <a:t>Measured: 10 of 21 team-written test sentences (Hindi, Tamil, English, Kannada)</a:t>
             </a:r>
             <a:endParaRPr lang="en-US" sz="900" dirty="0"/>
           </a:p>
@@ -17859,7 +17859,7 @@
                 <a:ea typeface="Calibri" pitchFamily="34" charset="-122"/>
                 <a:cs typeface="Calibri" pitchFamily="34" charset="-120"/>
               </a:rPr>
-              <a:t>VoBiz + Sarvam + ElevenLabs voice path · Claude safety gate · Dodo action path · Freshdesk escalation · Hindi + Tamil + English · audit trail</a:t>
+              <a:t>VoBiz + Sarvam + ElevenLabs voice path · Claude safety gate · Dodo action path · Freshdesk escalation · Hindi + Tamil + English + Kannada · audit trail</a:t>
             </a:r>
             <a:endParaRPr lang="en-US" sz="1100" dirty="0"/>
           </a:p>
@@ -18107,7 +18107,7 @@
                 <a:ea typeface="Calibri" pitchFamily="34" charset="-122"/>
                 <a:cs typeface="Calibri" pitchFamily="34" charset="-120"/>
               </a:rPr>
-              <a:t>11 of 23 → 0 of 23 </a:t>
+              <a:t>10 of 21 → 0 of 21 </a:t>
             </a:r>
             <a:pPr indent="0" marL="0">
               <a:buNone/>
@@ -18121,7 +18121,7 @@
                 <a:ea typeface="Calibri" pitchFamily="34" charset="-122"/>
                 <a:cs typeface="Calibri" pitchFamily="34" charset="-120"/>
               </a:rPr>
-              <a:t>wrong actions; 0 of 20 genuine requests blocked. 43 team-written sentences in 6 languages; the pilot measures real calls.</a:t>
+              <a:t>wrong actions; 0 of 18 genuine requests blocked. 39 team-written sentences in Hindi, Tamil, English and Kannada; the pilot measures real calls.</a:t>
             </a:r>
             <a:endParaRPr lang="en-US" sz="1050" dirty="0"/>
           </a:p>

</xml_diff>